<commit_message>
Final exports and slide browser images
</commit_message>
<xml_diff>
--- a/export/Sovereign by habit.pptx
+++ b/export/Sovereign by habit.pptx
@@ -6492,7 +6492,7 @@
       </p:sp>
       <p:pic>
         <p:nvPicPr>
-          <p:cNvPr id="507" name="viz-10-00.svg" descr="viz-10-00.svg"/>
+          <p:cNvPr id="507" name="prog-10.png" descr="prog-10.png"/>
           <p:cNvPicPr>
             <a:picLocks noChangeAspect="1"/>
           </p:cNvPicPr>
@@ -6500,6 +6500,35 @@
         </p:nvPicPr>
         <p:blipFill>
           <a:blip r:embed="rId4">
+            <a:extLst/>
+          </a:blip>
+          <a:stretch>
+            <a:fillRect/>
+          </a:stretch>
+        </p:blipFill>
+        <p:spPr>
+          <a:xfrm>
+            <a:off x="17170400" y="12395200"/>
+            <a:ext cx="5842000" cy="406400"/>
+          </a:xfrm>
+          <a:prstGeom prst="rect">
+            <a:avLst/>
+          </a:prstGeom>
+          <a:ln w="12700">
+            <a:miter lim="400000"/>
+          </a:ln>
+        </p:spPr>
+      </p:pic>
+      <p:pic>
+        <p:nvPicPr>
+          <p:cNvPr id="508" name="viz-10-00.svg" descr="viz-10-00.svg"/>
+          <p:cNvPicPr>
+            <a:picLocks noChangeAspect="1"/>
+          </p:cNvPicPr>
+          <p:nvPr/>
+        </p:nvPicPr>
+        <p:blipFill>
+          <a:blip r:embed="rId5">
             <a:extLst/>
           </a:blip>
           <a:stretch>
@@ -6521,14 +6550,14 @@
       </p:pic>
       <p:pic>
         <p:nvPicPr>
-          <p:cNvPr id="508" name="viz-10-01.svg" descr="viz-10-01.svg"/>
-          <p:cNvPicPr>
-            <a:picLocks noChangeAspect="1"/>
-          </p:cNvPicPr>
-          <p:nvPr/>
-        </p:nvPicPr>
-        <p:blipFill>
-          <a:blip r:embed="rId5">
+          <p:cNvPr id="509" name="viz-10-01.svg" descr="viz-10-01.svg"/>
+          <p:cNvPicPr>
+            <a:picLocks noChangeAspect="1"/>
+          </p:cNvPicPr>
+          <p:nvPr/>
+        </p:nvPicPr>
+        <p:blipFill>
+          <a:blip r:embed="rId6">
             <a:extLst/>
           </a:blip>
           <a:stretch>
@@ -6550,14 +6579,14 @@
       </p:pic>
       <p:pic>
         <p:nvPicPr>
-          <p:cNvPr id="509" name="viz-10-02.svg" descr="viz-10-02.svg"/>
-          <p:cNvPicPr>
-            <a:picLocks noChangeAspect="1"/>
-          </p:cNvPicPr>
-          <p:nvPr/>
-        </p:nvPicPr>
-        <p:blipFill>
-          <a:blip r:embed="rId6">
+          <p:cNvPr id="510" name="viz-10-02.svg" descr="viz-10-02.svg"/>
+          <p:cNvPicPr>
+            <a:picLocks noChangeAspect="1"/>
+          </p:cNvPicPr>
+          <p:nvPr/>
+        </p:nvPicPr>
+        <p:blipFill>
+          <a:blip r:embed="rId7">
             <a:extLst/>
           </a:blip>
           <a:stretch>
@@ -6579,14 +6608,14 @@
       </p:pic>
       <p:pic>
         <p:nvPicPr>
-          <p:cNvPr id="510" name="viz-10-03.svg" descr="viz-10-03.svg"/>
-          <p:cNvPicPr>
-            <a:picLocks noChangeAspect="1"/>
-          </p:cNvPicPr>
-          <p:nvPr/>
-        </p:nvPicPr>
-        <p:blipFill>
-          <a:blip r:embed="rId7">
+          <p:cNvPr id="511" name="viz-10-03.svg" descr="viz-10-03.svg"/>
+          <p:cNvPicPr>
+            <a:picLocks noChangeAspect="1"/>
+          </p:cNvPicPr>
+          <p:nvPr/>
+        </p:nvPicPr>
+        <p:blipFill>
+          <a:blip r:embed="rId8">
             <a:extLst/>
           </a:blip>
           <a:stretch>
@@ -6608,14 +6637,14 @@
       </p:pic>
       <p:pic>
         <p:nvPicPr>
-          <p:cNvPr id="511" name="viz-10-04.svg" descr="viz-10-04.svg"/>
-          <p:cNvPicPr>
-            <a:picLocks noChangeAspect="1"/>
-          </p:cNvPicPr>
-          <p:nvPr/>
-        </p:nvPicPr>
-        <p:blipFill>
-          <a:blip r:embed="rId8">
+          <p:cNvPr id="512" name="viz-10-04.svg" descr="viz-10-04.svg"/>
+          <p:cNvPicPr>
+            <a:picLocks noChangeAspect="1"/>
+          </p:cNvPicPr>
+          <p:nvPr/>
+        </p:nvPicPr>
+        <p:blipFill>
+          <a:blip r:embed="rId9">
             <a:extLst/>
           </a:blip>
           <a:stretch>
@@ -6637,14 +6666,14 @@
       </p:pic>
       <p:pic>
         <p:nvPicPr>
-          <p:cNvPr id="512" name="viz-10-05.svg" descr="viz-10-05.svg"/>
-          <p:cNvPicPr>
-            <a:picLocks noChangeAspect="1"/>
-          </p:cNvPicPr>
-          <p:nvPr/>
-        </p:nvPicPr>
-        <p:blipFill>
-          <a:blip r:embed="rId7">
+          <p:cNvPr id="513" name="viz-10-05.svg" descr="viz-10-05.svg"/>
+          <p:cNvPicPr>
+            <a:picLocks noChangeAspect="1"/>
+          </p:cNvPicPr>
+          <p:nvPr/>
+        </p:nvPicPr>
+        <p:blipFill>
+          <a:blip r:embed="rId8">
             <a:extLst/>
           </a:blip>
           <a:stretch>
@@ -6666,14 +6695,14 @@
       </p:pic>
       <p:pic>
         <p:nvPicPr>
-          <p:cNvPr id="513" name="viz-10-06.svg" descr="viz-10-06.svg"/>
-          <p:cNvPicPr>
-            <a:picLocks noChangeAspect="1"/>
-          </p:cNvPicPr>
-          <p:nvPr/>
-        </p:nvPicPr>
-        <p:blipFill>
-          <a:blip r:embed="rId9">
+          <p:cNvPr id="514" name="viz-10-06.svg" descr="viz-10-06.svg"/>
+          <p:cNvPicPr>
+            <a:picLocks noChangeAspect="1"/>
+          </p:cNvPicPr>
+          <p:nvPr/>
+        </p:nvPicPr>
+        <p:blipFill>
+          <a:blip r:embed="rId10">
             <a:extLst/>
           </a:blip>
           <a:stretch>
@@ -6695,14 +6724,14 @@
       </p:pic>
       <p:pic>
         <p:nvPicPr>
-          <p:cNvPr id="514" name="viz-10-07.svg" descr="viz-10-07.svg"/>
-          <p:cNvPicPr>
-            <a:picLocks noChangeAspect="1"/>
-          </p:cNvPicPr>
-          <p:nvPr/>
-        </p:nvPicPr>
-        <p:blipFill>
-          <a:blip r:embed="rId10">
+          <p:cNvPr id="515" name="viz-10-07.svg" descr="viz-10-07.svg"/>
+          <p:cNvPicPr>
+            <a:picLocks noChangeAspect="1"/>
+          </p:cNvPicPr>
+          <p:nvPr/>
+        </p:nvPicPr>
+        <p:blipFill>
+          <a:blip r:embed="rId8">
             <a:extLst/>
           </a:blip>
           <a:stretch>
@@ -6724,7 +6753,7 @@
       </p:pic>
       <p:pic>
         <p:nvPicPr>
-          <p:cNvPr id="515" name="viz-10-08.svg" descr="viz-10-08.svg"/>
+          <p:cNvPr id="516" name="viz-10-08.svg" descr="viz-10-08.svg"/>
           <p:cNvPicPr>
             <a:picLocks noChangeAspect="1"/>
           </p:cNvPicPr>
@@ -6753,14 +6782,14 @@
       </p:pic>
       <p:pic>
         <p:nvPicPr>
-          <p:cNvPr id="516" name="viz-10-09.svg" descr="viz-10-09.svg"/>
-          <p:cNvPicPr>
-            <a:picLocks noChangeAspect="1"/>
-          </p:cNvPicPr>
-          <p:nvPr/>
-        </p:nvPicPr>
-        <p:blipFill>
-          <a:blip r:embed="rId7">
+          <p:cNvPr id="517" name="viz-10-09.svg" descr="viz-10-09.svg"/>
+          <p:cNvPicPr>
+            <a:picLocks noChangeAspect="1"/>
+          </p:cNvPicPr>
+          <p:nvPr/>
+        </p:nvPicPr>
+        <p:blipFill>
+          <a:blip r:embed="rId8">
             <a:extLst/>
           </a:blip>
           <a:stretch>
@@ -6782,7 +6811,7 @@
       </p:pic>
       <p:pic>
         <p:nvPicPr>
-          <p:cNvPr id="517" name="viz-10-10.svg" descr="viz-10-10.svg"/>
+          <p:cNvPr id="518" name="viz-10-10.svg" descr="viz-10-10.svg"/>
           <p:cNvPicPr>
             <a:picLocks noChangeAspect="1"/>
           </p:cNvPicPr>
@@ -6811,14 +6840,14 @@
       </p:pic>
       <p:pic>
         <p:nvPicPr>
-          <p:cNvPr id="518" name="viz-10-11.svg" descr="viz-10-11.svg"/>
-          <p:cNvPicPr>
-            <a:picLocks noChangeAspect="1"/>
-          </p:cNvPicPr>
-          <p:nvPr/>
-        </p:nvPicPr>
-        <p:blipFill>
-          <a:blip r:embed="rId7">
+          <p:cNvPr id="519" name="viz-10-11.svg" descr="viz-10-11.svg"/>
+          <p:cNvPicPr>
+            <a:picLocks noChangeAspect="1"/>
+          </p:cNvPicPr>
+          <p:nvPr/>
+        </p:nvPicPr>
+        <p:blipFill>
+          <a:blip r:embed="rId8">
             <a:extLst/>
           </a:blip>
           <a:stretch>
@@ -6840,7 +6869,7 @@
       </p:pic>
       <p:pic>
         <p:nvPicPr>
-          <p:cNvPr id="519" name="viz-10-12.svg" descr="viz-10-12.svg"/>
+          <p:cNvPr id="520" name="viz-10-12.svg" descr="viz-10-12.svg"/>
           <p:cNvPicPr>
             <a:picLocks noChangeAspect="1"/>
           </p:cNvPicPr>
@@ -6869,14 +6898,14 @@
       </p:pic>
       <p:pic>
         <p:nvPicPr>
-          <p:cNvPr id="520" name="viz-10-13.svg" descr="viz-10-13.svg"/>
-          <p:cNvPicPr>
-            <a:picLocks noChangeAspect="1"/>
-          </p:cNvPicPr>
-          <p:nvPr/>
-        </p:nvPicPr>
-        <p:blipFill>
-          <a:blip r:embed="rId7">
+          <p:cNvPr id="521" name="viz-10-13.svg" descr="viz-10-13.svg"/>
+          <p:cNvPicPr>
+            <a:picLocks noChangeAspect="1"/>
+          </p:cNvPicPr>
+          <p:nvPr/>
+        </p:nvPicPr>
+        <p:blipFill>
+          <a:blip r:embed="rId8">
             <a:extLst/>
           </a:blip>
           <a:stretch>
@@ -6898,7 +6927,7 @@
       </p:pic>
       <p:sp>
         <p:nvSpPr>
-          <p:cNvPr id="521" name="2015"/>
+          <p:cNvPr id="522" name="2015"/>
           <p:cNvSpPr txBox="1"/>
           <p:nvPr/>
         </p:nvSpPr>
@@ -6946,7 +6975,7 @@
       </p:sp>
       <p:sp>
         <p:nvSpPr>
-          <p:cNvPr id="522" name="A US cloud"/>
+          <p:cNvPr id="523" name="A US cloud"/>
           <p:cNvSpPr txBox="1"/>
           <p:nvPr/>
         </p:nvSpPr>
@@ -6994,7 +7023,7 @@
       </p:sp>
       <p:sp>
         <p:nvSpPr>
-          <p:cNvPr id="523" name="The first VPS."/>
+          <p:cNvPr id="524" name="The first VPS."/>
           <p:cNvSpPr txBox="1"/>
           <p:nvPr/>
         </p:nvSpPr>
@@ -7042,7 +7071,7 @@
       </p:sp>
       <p:sp>
         <p:nvSpPr>
-          <p:cNvPr id="524" name="2016"/>
+          <p:cNvPr id="525" name="2016"/>
           <p:cNvSpPr txBox="1"/>
           <p:nvPr/>
         </p:nvSpPr>
@@ -7090,7 +7119,7 @@
       </p:sp>
       <p:sp>
         <p:nvSpPr>
-          <p:cNvPr id="525" name="In France"/>
+          <p:cNvPr id="526" name="In France"/>
           <p:cNvSpPr txBox="1"/>
           <p:nvPr/>
         </p:nvSpPr>
@@ -7138,7 +7167,7 @@
       </p:sp>
       <p:sp>
         <p:nvSpPr>
-          <p:cNvPr id="526" name="2 web, 2 database and 1 file server."/>
+          <p:cNvPr id="527" name="2 web, 2 database and 1 file server."/>
           <p:cNvSpPr txBox="1"/>
           <p:nvPr/>
         </p:nvSpPr>
@@ -7188,7 +7217,7 @@
       </p:sp>
       <p:sp>
         <p:nvSpPr>
-          <p:cNvPr id="527" name="2016"/>
+          <p:cNvPr id="528" name="2016"/>
           <p:cNvSpPr txBox="1"/>
           <p:nvPr/>
         </p:nvSpPr>
@@ -7236,7 +7265,7 @@
       </p:sp>
       <p:sp>
         <p:nvSpPr>
-          <p:cNvPr id="528" name="The outage"/>
+          <p:cNvPr id="529" name="The outage"/>
           <p:cNvSpPr txBox="1"/>
           <p:nvPr/>
         </p:nvSpPr>
@@ -7284,7 +7313,7 @@
       </p:sp>
       <p:sp>
         <p:nvSpPr>
-          <p:cNvPr id="529" name="Every client site hangs."/>
+          <p:cNvPr id="530" name="Every client site hangs."/>
           <p:cNvSpPr txBox="1"/>
           <p:nvPr/>
         </p:nvSpPr>
@@ -7334,7 +7363,7 @@
       </p:sp>
       <p:sp>
         <p:nvSpPr>
-          <p:cNvPr id="530" name="2016"/>
+          <p:cNvPr id="531" name="2016"/>
           <p:cNvSpPr txBox="1"/>
           <p:nvPr/>
         </p:nvSpPr>
@@ -7382,7 +7411,7 @@
       </p:sp>
       <p:sp>
         <p:nvSpPr>
-          <p:cNvPr id="531" name="The move"/>
+          <p:cNvPr id="532" name="The move"/>
           <p:cNvSpPr txBox="1"/>
           <p:nvPr/>
         </p:nvSpPr>
@@ -7430,7 +7459,7 @@
       </p:sp>
       <p:sp>
         <p:nvSpPr>
-          <p:cNvPr id="532" name="Every site moved to a local data center in Finland."/>
+          <p:cNvPr id="533" name="Every site moved to a local data center in Finland."/>
           <p:cNvSpPr txBox="1"/>
           <p:nvPr/>
         </p:nvSpPr>
@@ -7484,7 +7513,7 @@
       </p:sp>
       <p:sp>
         <p:nvSpPr>
-          <p:cNvPr id="533" name="Since 2016"/>
+          <p:cNvPr id="534" name="Since 2016"/>
           <p:cNvSpPr txBox="1"/>
           <p:nvPr/>
         </p:nvSpPr>
@@ -7532,7 +7561,7 @@
       </p:sp>
       <p:sp>
         <p:nvSpPr>
-          <p:cNvPr id="534" name="The rock cave"/>
+          <p:cNvPr id="535" name="The rock cave"/>
           <p:cNvSpPr txBox="1"/>
           <p:nvPr/>
         </p:nvSpPr>
@@ -7580,7 +7609,7 @@
       </p:sp>
       <p:sp>
         <p:nvSpPr>
-          <p:cNvPr id="535" name="A datacentre in a former army rock cave, on wind power."/>
+          <p:cNvPr id="536" name="A datacentre in a former army rock cave, on wind power."/>
           <p:cNvSpPr txBox="1"/>
           <p:nvPr/>
         </p:nvSpPr>
@@ -7634,7 +7663,7 @@
       </p:sp>
       <p:sp>
         <p:nvSpPr>
-          <p:cNvPr id="536" name="2026"/>
+          <p:cNvPr id="537" name="2026"/>
           <p:cNvSpPr txBox="1"/>
           <p:nvPr/>
         </p:nvSpPr>
@@ -7682,7 +7711,7 @@
       </p:sp>
       <p:sp>
         <p:nvSpPr>
-          <p:cNvPr id="537" name="Today"/>
+          <p:cNvPr id="538" name="Today"/>
           <p:cNvSpPr txBox="1"/>
           <p:nvPr/>
         </p:nvSpPr>
@@ -7730,7 +7759,7 @@
       </p:sp>
       <p:sp>
         <p:nvSpPr>
-          <p:cNvPr id="538" name="Still on European servers, data on sovereign ground."/>
+          <p:cNvPr id="539" name="Still on European servers, data on sovereign ground."/>
           <p:cNvSpPr txBox="1"/>
           <p:nvPr/>
         </p:nvSpPr>
@@ -7778,35 +7807,6 @@
           </a:p>
         </p:txBody>
       </p:sp>
-      <p:pic>
-        <p:nvPicPr>
-          <p:cNvPr id="539" name="prog-10.png" descr="prog-10.png"/>
-          <p:cNvPicPr>
-            <a:picLocks noChangeAspect="1"/>
-          </p:cNvPicPr>
-          <p:nvPr/>
-        </p:nvPicPr>
-        <p:blipFill>
-          <a:blip r:embed="rId14">
-            <a:extLst/>
-          </a:blip>
-          <a:stretch>
-            <a:fillRect/>
-          </a:stretch>
-        </p:blipFill>
-        <p:spPr>
-          <a:xfrm>
-            <a:off x="17170400" y="12395200"/>
-            <a:ext cx="5842000" cy="406400"/>
-          </a:xfrm>
-          <a:prstGeom prst="rect">
-            <a:avLst/>
-          </a:prstGeom>
-          <a:ln w="12700">
-            <a:miter lim="400000"/>
-          </a:ln>
-        </p:spPr>
-      </p:pic>
     </p:spTree>
   </p:cSld>
   <p:clrMapOvr>
@@ -9600,8 +9600,8 @@
         </p:nvSpPr>
         <p:spPr>
           <a:xfrm>
-            <a:off x="12598400" y="5016500"/>
-            <a:ext cx="4470400" cy="457200"/>
+            <a:off x="12598400" y="5016499"/>
+            <a:ext cx="4470400" cy="457201"/>
           </a:xfrm>
           <a:prstGeom prst="rect">
             <a:avLst/>
@@ -9648,8 +9648,8 @@
         </p:nvSpPr>
         <p:spPr>
           <a:xfrm>
-            <a:off x="12598400" y="5727700"/>
-            <a:ext cx="4470400" cy="457200"/>
+            <a:off x="12598400" y="5727699"/>
+            <a:ext cx="4470400" cy="457201"/>
           </a:xfrm>
           <a:prstGeom prst="rect">
             <a:avLst/>
@@ -9696,8 +9696,8 @@
         </p:nvSpPr>
         <p:spPr>
           <a:xfrm>
-            <a:off x="12598400" y="6438900"/>
-            <a:ext cx="4470400" cy="457200"/>
+            <a:off x="12598400" y="6438899"/>
+            <a:ext cx="4470400" cy="457201"/>
           </a:xfrm>
           <a:prstGeom prst="rect">
             <a:avLst/>
@@ -9744,8 +9744,8 @@
         </p:nvSpPr>
         <p:spPr>
           <a:xfrm>
-            <a:off x="12598400" y="7150100"/>
-            <a:ext cx="4470400" cy="457200"/>
+            <a:off x="12598400" y="7150099"/>
+            <a:ext cx="4470400" cy="457201"/>
           </a:xfrm>
           <a:prstGeom prst="rect">
             <a:avLst/>
@@ -9792,8 +9792,8 @@
         </p:nvSpPr>
         <p:spPr>
           <a:xfrm>
-            <a:off x="12598400" y="7861300"/>
-            <a:ext cx="4470400" cy="457200"/>
+            <a:off x="12598400" y="7861299"/>
+            <a:ext cx="4470400" cy="457201"/>
           </a:xfrm>
           <a:prstGeom prst="rect">
             <a:avLst/>
@@ -10272,8 +10272,8 @@
         </p:nvSpPr>
         <p:spPr>
           <a:xfrm>
-            <a:off x="12395200" y="10185400"/>
-            <a:ext cx="4597289" cy="777240"/>
+            <a:off x="12395200" y="10185399"/>
+            <a:ext cx="4597289" cy="777241"/>
           </a:xfrm>
           <a:prstGeom prst="rect">
             <a:avLst/>
@@ -10368,8 +10368,8 @@
         </p:nvSpPr>
         <p:spPr>
           <a:xfrm>
-            <a:off x="17932399" y="10185399"/>
-            <a:ext cx="4318001" cy="777241"/>
+            <a:off x="17932400" y="10185399"/>
+            <a:ext cx="4318000" cy="777241"/>
           </a:xfrm>
           <a:prstGeom prst="rect">
             <a:avLst/>
@@ -11215,8 +11215,8 @@
         </p:nvSpPr>
         <p:spPr>
           <a:xfrm>
-            <a:off x="2514599" y="5321300"/>
-            <a:ext cx="4851401" cy="457200"/>
+            <a:off x="2514600" y="5321299"/>
+            <a:ext cx="4851400" cy="457201"/>
           </a:xfrm>
           <a:prstGeom prst="rect">
             <a:avLst/>
@@ -11263,8 +11263,8 @@
         </p:nvSpPr>
         <p:spPr>
           <a:xfrm>
-            <a:off x="2514599" y="5740400"/>
-            <a:ext cx="4851401" cy="431800"/>
+            <a:off x="2514600" y="5740399"/>
+            <a:ext cx="4851400" cy="431801"/>
           </a:xfrm>
           <a:prstGeom prst="rect">
             <a:avLst/>
@@ -11311,8 +11311,8 @@
         </p:nvSpPr>
         <p:spPr>
           <a:xfrm>
-            <a:off x="2514599" y="7226300"/>
-            <a:ext cx="4851401" cy="457200"/>
+            <a:off x="2514600" y="7226299"/>
+            <a:ext cx="4851400" cy="457201"/>
           </a:xfrm>
           <a:prstGeom prst="rect">
             <a:avLst/>
@@ -11359,8 +11359,8 @@
         </p:nvSpPr>
         <p:spPr>
           <a:xfrm>
-            <a:off x="2514599" y="7645400"/>
-            <a:ext cx="4851401" cy="431800"/>
+            <a:off x="2514600" y="7645399"/>
+            <a:ext cx="4851400" cy="431801"/>
           </a:xfrm>
           <a:prstGeom prst="rect">
             <a:avLst/>
@@ -11407,8 +11407,8 @@
         </p:nvSpPr>
         <p:spPr>
           <a:xfrm>
-            <a:off x="2514599" y="8966200"/>
-            <a:ext cx="4851401" cy="457200"/>
+            <a:off x="2514600" y="8966199"/>
+            <a:ext cx="4851400" cy="457201"/>
           </a:xfrm>
           <a:prstGeom prst="rect">
             <a:avLst/>
@@ -11455,8 +11455,8 @@
         </p:nvSpPr>
         <p:spPr>
           <a:xfrm>
-            <a:off x="2514599" y="9385300"/>
-            <a:ext cx="4851401" cy="728980"/>
+            <a:off x="2514600" y="9385300"/>
+            <a:ext cx="4851400" cy="728981"/>
           </a:xfrm>
           <a:prstGeom prst="rect">
             <a:avLst/>
@@ -11505,8 +11505,8 @@
         </p:nvSpPr>
         <p:spPr>
           <a:xfrm>
-            <a:off x="9829800" y="5156200"/>
-            <a:ext cx="2819400" cy="457200"/>
+            <a:off x="9829800" y="5156199"/>
+            <a:ext cx="2819400" cy="457201"/>
           </a:xfrm>
           <a:prstGeom prst="rect">
             <a:avLst/>
@@ -11554,7 +11554,7 @@
         <p:spPr>
           <a:xfrm>
             <a:off x="9829800" y="5575300"/>
-            <a:ext cx="2819400" cy="728980"/>
+            <a:ext cx="2819400" cy="728981"/>
           </a:xfrm>
           <a:prstGeom prst="rect">
             <a:avLst/>
@@ -11603,8 +11603,8 @@
         </p:nvSpPr>
         <p:spPr>
           <a:xfrm>
-            <a:off x="15417800" y="5397500"/>
-            <a:ext cx="5080000" cy="457200"/>
+            <a:off x="15417800" y="5397499"/>
+            <a:ext cx="5080000" cy="457201"/>
           </a:xfrm>
           <a:prstGeom prst="rect">
             <a:avLst/>
@@ -11651,8 +11651,8 @@
         </p:nvSpPr>
         <p:spPr>
           <a:xfrm>
-            <a:off x="14833600" y="6273800"/>
-            <a:ext cx="3556000" cy="457200"/>
+            <a:off x="14833600" y="6273799"/>
+            <a:ext cx="3556000" cy="457201"/>
           </a:xfrm>
           <a:prstGeom prst="rect">
             <a:avLst/>
@@ -11699,8 +11699,8 @@
         </p:nvSpPr>
         <p:spPr>
           <a:xfrm>
-            <a:off x="18973800" y="6273800"/>
-            <a:ext cx="3556000" cy="457200"/>
+            <a:off x="18973800" y="6273799"/>
+            <a:ext cx="3556000" cy="457201"/>
           </a:xfrm>
           <a:prstGeom prst="rect">
             <a:avLst/>
@@ -11747,8 +11747,8 @@
         </p:nvSpPr>
         <p:spPr>
           <a:xfrm>
-            <a:off x="14833600" y="7086600"/>
-            <a:ext cx="3556000" cy="457200"/>
+            <a:off x="14833600" y="7086599"/>
+            <a:ext cx="3556000" cy="457201"/>
           </a:xfrm>
           <a:prstGeom prst="rect">
             <a:avLst/>
@@ -11795,8 +11795,8 @@
         </p:nvSpPr>
         <p:spPr>
           <a:xfrm>
-            <a:off x="18973800" y="7086600"/>
-            <a:ext cx="3556000" cy="457200"/>
+            <a:off x="18973800" y="7086599"/>
+            <a:ext cx="3556000" cy="457201"/>
           </a:xfrm>
           <a:prstGeom prst="rect">
             <a:avLst/>
@@ -11843,8 +11843,8 @@
         </p:nvSpPr>
         <p:spPr>
           <a:xfrm>
-            <a:off x="14833600" y="7899400"/>
-            <a:ext cx="3556000" cy="457200"/>
+            <a:off x="14833600" y="7899399"/>
+            <a:ext cx="3556000" cy="457201"/>
           </a:xfrm>
           <a:prstGeom prst="rect">
             <a:avLst/>
@@ -11891,8 +11891,8 @@
         </p:nvSpPr>
         <p:spPr>
           <a:xfrm>
-            <a:off x="18973800" y="7899400"/>
-            <a:ext cx="3556000" cy="457200"/>
+            <a:off x="18973800" y="7899399"/>
+            <a:ext cx="3556000" cy="457201"/>
           </a:xfrm>
           <a:prstGeom prst="rect">
             <a:avLst/>
@@ -11939,8 +11939,8 @@
         </p:nvSpPr>
         <p:spPr>
           <a:xfrm>
-            <a:off x="14833600" y="8915400"/>
-            <a:ext cx="7620000" cy="457200"/>
+            <a:off x="14833600" y="8915399"/>
+            <a:ext cx="7620000" cy="457201"/>
           </a:xfrm>
           <a:prstGeom prst="rect">
             <a:avLst/>
@@ -11988,7 +11988,7 @@
         <p:spPr>
           <a:xfrm>
             <a:off x="14833600" y="9347200"/>
-            <a:ext cx="7620000" cy="728980"/>
+            <a:ext cx="7620000" cy="728981"/>
           </a:xfrm>
           <a:prstGeom prst="rect">
             <a:avLst/>
@@ -12430,7 +12430,7 @@
         <p:spPr>
           <a:xfrm>
             <a:off x="1752600" y="5740400"/>
-            <a:ext cx="2133601" cy="533400"/>
+            <a:ext cx="2133600" cy="533401"/>
           </a:xfrm>
           <a:prstGeom prst="rect">
             <a:avLst/>
@@ -12492,7 +12492,7 @@
         <p:spPr>
           <a:xfrm>
             <a:off x="1752600" y="6248400"/>
-            <a:ext cx="6604000" cy="533400"/>
+            <a:ext cx="6604000" cy="533401"/>
           </a:xfrm>
           <a:prstGeom prst="rect">
             <a:avLst/>
@@ -12614,7 +12614,7 @@
         <p:spPr>
           <a:xfrm>
             <a:off x="12992100" y="5740400"/>
-            <a:ext cx="9042400" cy="533400"/>
+            <a:ext cx="9042400" cy="533401"/>
           </a:xfrm>
           <a:prstGeom prst="rect">
             <a:avLst/>
@@ -12687,7 +12687,7 @@
         <p:spPr>
           <a:xfrm>
             <a:off x="12992100" y="6248400"/>
-            <a:ext cx="8229600" cy="533400"/>
+            <a:ext cx="8229600" cy="533401"/>
           </a:xfrm>
           <a:prstGeom prst="rect">
             <a:avLst/>
@@ -12793,7 +12793,7 @@
         <p:spPr>
           <a:xfrm>
             <a:off x="12992100" y="6756400"/>
-            <a:ext cx="6604000" cy="533400"/>
+            <a:ext cx="6604000" cy="533401"/>
           </a:xfrm>
           <a:prstGeom prst="rect">
             <a:avLst/>
@@ -12866,7 +12866,7 @@
         <p:spPr>
           <a:xfrm>
             <a:off x="12992100" y="7264400"/>
-            <a:ext cx="8839200" cy="533400"/>
+            <a:ext cx="8839200" cy="533401"/>
           </a:xfrm>
           <a:prstGeom prst="rect">
             <a:avLst/>
@@ -12936,7 +12936,7 @@
         <p:spPr>
           <a:xfrm>
             <a:off x="12992100" y="7772400"/>
-            <a:ext cx="2946400" cy="533400"/>
+            <a:ext cx="2946400" cy="533401"/>
           </a:xfrm>
           <a:prstGeom prst="rect">
             <a:avLst/>
@@ -14268,7 +14268,7 @@
         <p:spPr>
           <a:xfrm>
             <a:off x="2082800" y="5295900"/>
-            <a:ext cx="20955001" cy="723900"/>
+            <a:ext cx="20955000" cy="723901"/>
           </a:xfrm>
           <a:prstGeom prst="rect">
             <a:avLst/>
@@ -14652,7 +14652,7 @@
         <p:spPr>
           <a:xfrm>
             <a:off x="1320800" y="9702800"/>
-            <a:ext cx="552019" cy="723900"/>
+            <a:ext cx="552019" cy="723901"/>
           </a:xfrm>
           <a:prstGeom prst="rect">
             <a:avLst/>
@@ -14700,7 +14700,7 @@
         <p:spPr>
           <a:xfrm>
             <a:off x="2082800" y="9702800"/>
-            <a:ext cx="20955000" cy="723900"/>
+            <a:ext cx="20955000" cy="723901"/>
           </a:xfrm>
           <a:prstGeom prst="rect">
             <a:avLst/>
@@ -15129,7 +15129,7 @@
         </p:nvSpPr>
         <p:spPr>
           <a:xfrm>
-            <a:off x="2082800" y="7505699"/>
+            <a:off x="2082800" y="7505700"/>
             <a:ext cx="19064404" cy="723901"/>
           </a:xfrm>
           <a:prstGeom prst="rect">
@@ -17434,8 +17434,8 @@
         </p:nvSpPr>
         <p:spPr>
           <a:xfrm>
-            <a:off x="16230600" y="7073900"/>
-            <a:ext cx="1549400" cy="508000"/>
+            <a:off x="16230600" y="7073899"/>
+            <a:ext cx="1549400" cy="508001"/>
           </a:xfrm>
           <a:prstGeom prst="rect">
             <a:avLst/>
@@ -17483,7 +17483,7 @@
         <p:spPr>
           <a:xfrm>
             <a:off x="20853400" y="4902200"/>
-            <a:ext cx="1803400" cy="533400"/>
+            <a:ext cx="1803400" cy="533401"/>
           </a:xfrm>
           <a:prstGeom prst="rect">
             <a:avLst/>
@@ -17531,7 +17531,7 @@
         <p:spPr>
           <a:xfrm>
             <a:off x="20853400" y="7061200"/>
-            <a:ext cx="1803400" cy="533400"/>
+            <a:ext cx="1803400" cy="533401"/>
           </a:xfrm>
           <a:prstGeom prst="rect">
             <a:avLst/>
@@ -17579,7 +17579,7 @@
         <p:spPr>
           <a:xfrm>
             <a:off x="20853400" y="9220200"/>
-            <a:ext cx="1803400" cy="533400"/>
+            <a:ext cx="1803400" cy="533401"/>
           </a:xfrm>
           <a:prstGeom prst="rect">
             <a:avLst/>
@@ -19529,8 +19529,8 @@
         </p:nvSpPr>
         <p:spPr>
           <a:xfrm>
-            <a:off x="1295400" y="7213600"/>
-            <a:ext cx="10744200" cy="762000"/>
+            <a:off x="1295400" y="7213599"/>
+            <a:ext cx="10744200" cy="762001"/>
           </a:xfrm>
           <a:prstGeom prst="rect">
             <a:avLst/>
@@ -19625,8 +19625,8 @@
         </p:nvSpPr>
         <p:spPr>
           <a:xfrm>
-            <a:off x="12801600" y="7213600"/>
-            <a:ext cx="10744200" cy="762000"/>
+            <a:off x="12801600" y="7213599"/>
+            <a:ext cx="10744200" cy="762001"/>
           </a:xfrm>
           <a:prstGeom prst="rect">
             <a:avLst/>
@@ -19673,8 +19673,8 @@
         </p:nvSpPr>
         <p:spPr>
           <a:xfrm>
-            <a:off x="12826999" y="8039099"/>
-            <a:ext cx="9369454" cy="1163321"/>
+            <a:off x="12827000" y="8039099"/>
+            <a:ext cx="9369453" cy="1163321"/>
           </a:xfrm>
           <a:prstGeom prst="rect">
             <a:avLst/>
@@ -20405,7 +20405,7 @@
         <p:spPr>
           <a:xfrm>
             <a:off x="18126075" y="635000"/>
-            <a:ext cx="5651500" cy="1638301"/>
+            <a:ext cx="5651500" cy="1638300"/>
           </a:xfrm>
           <a:prstGeom prst="rect">
             <a:avLst/>
@@ -20423,8 +20423,8 @@
         </p:nvSpPr>
         <p:spPr>
           <a:xfrm>
-            <a:off x="1320800" y="4826000"/>
-            <a:ext cx="5588000" cy="546100"/>
+            <a:off x="1320800" y="4825999"/>
+            <a:ext cx="5588000" cy="546101"/>
           </a:xfrm>
           <a:prstGeom prst="rect">
             <a:avLst/>
@@ -20471,8 +20471,8 @@
         </p:nvSpPr>
         <p:spPr>
           <a:xfrm>
-            <a:off x="7874000" y="4826000"/>
-            <a:ext cx="6604000" cy="546100"/>
+            <a:off x="7874000" y="4825999"/>
+            <a:ext cx="6604000" cy="546101"/>
           </a:xfrm>
           <a:prstGeom prst="rect">
             <a:avLst/>
@@ -20519,8 +20519,8 @@
         </p:nvSpPr>
         <p:spPr>
           <a:xfrm>
-            <a:off x="14986000" y="4826000"/>
-            <a:ext cx="7620000" cy="546100"/>
+            <a:off x="14986000" y="4825999"/>
+            <a:ext cx="7620000" cy="546101"/>
           </a:xfrm>
           <a:prstGeom prst="rect">
             <a:avLst/>
@@ -20567,8 +20567,8 @@
         </p:nvSpPr>
         <p:spPr>
           <a:xfrm>
-            <a:off x="1625600" y="5816600"/>
-            <a:ext cx="5080000" cy="508000"/>
+            <a:off x="1625600" y="5816599"/>
+            <a:ext cx="5080000" cy="508001"/>
           </a:xfrm>
           <a:prstGeom prst="rect">
             <a:avLst/>
@@ -20615,8 +20615,8 @@
         </p:nvSpPr>
         <p:spPr>
           <a:xfrm>
-            <a:off x="8178800" y="5816600"/>
-            <a:ext cx="6096000" cy="508000"/>
+            <a:off x="8178800" y="5816599"/>
+            <a:ext cx="6096000" cy="508001"/>
           </a:xfrm>
           <a:prstGeom prst="rect">
             <a:avLst/>
@@ -20664,7 +20664,7 @@
         <p:spPr>
           <a:xfrm>
             <a:off x="14986000" y="5816600"/>
-            <a:ext cx="8128000" cy="495300"/>
+            <a:ext cx="8128000" cy="495301"/>
           </a:xfrm>
           <a:prstGeom prst="rect">
             <a:avLst/>
@@ -20711,8 +20711,8 @@
         </p:nvSpPr>
         <p:spPr>
           <a:xfrm>
-            <a:off x="1625600" y="6985000"/>
-            <a:ext cx="5080000" cy="508000"/>
+            <a:off x="1625600" y="6984999"/>
+            <a:ext cx="5080000" cy="508001"/>
           </a:xfrm>
           <a:prstGeom prst="rect">
             <a:avLst/>
@@ -20759,8 +20759,8 @@
         </p:nvSpPr>
         <p:spPr>
           <a:xfrm>
-            <a:off x="8178800" y="6985000"/>
-            <a:ext cx="6096000" cy="508000"/>
+            <a:off x="8178800" y="6984999"/>
+            <a:ext cx="6096000" cy="508001"/>
           </a:xfrm>
           <a:prstGeom prst="rect">
             <a:avLst/>
@@ -20808,7 +20808,7 @@
         <p:spPr>
           <a:xfrm>
             <a:off x="14986000" y="6985000"/>
-            <a:ext cx="8128000" cy="495300"/>
+            <a:ext cx="8128000" cy="495301"/>
           </a:xfrm>
           <a:prstGeom prst="rect">
             <a:avLst/>
@@ -20855,8 +20855,8 @@
         </p:nvSpPr>
         <p:spPr>
           <a:xfrm>
-            <a:off x="1625600" y="8153400"/>
-            <a:ext cx="5080000" cy="508000"/>
+            <a:off x="1625600" y="8153399"/>
+            <a:ext cx="5080000" cy="508001"/>
           </a:xfrm>
           <a:prstGeom prst="rect">
             <a:avLst/>
@@ -20903,8 +20903,8 @@
         </p:nvSpPr>
         <p:spPr>
           <a:xfrm>
-            <a:off x="8178800" y="8153400"/>
-            <a:ext cx="6096000" cy="508000"/>
+            <a:off x="8178800" y="8153399"/>
+            <a:ext cx="6096000" cy="508001"/>
           </a:xfrm>
           <a:prstGeom prst="rect">
             <a:avLst/>
@@ -20952,7 +20952,7 @@
         <p:spPr>
           <a:xfrm>
             <a:off x="14986000" y="8153400"/>
-            <a:ext cx="8128000" cy="495300"/>
+            <a:ext cx="8128000" cy="495301"/>
           </a:xfrm>
           <a:prstGeom prst="rect">
             <a:avLst/>
@@ -20999,8 +20999,8 @@
         </p:nvSpPr>
         <p:spPr>
           <a:xfrm>
-            <a:off x="1625600" y="9321800"/>
-            <a:ext cx="5080000" cy="508000"/>
+            <a:off x="1625600" y="9321799"/>
+            <a:ext cx="5080000" cy="508001"/>
           </a:xfrm>
           <a:prstGeom prst="rect">
             <a:avLst/>
@@ -21047,8 +21047,8 @@
         </p:nvSpPr>
         <p:spPr>
           <a:xfrm>
-            <a:off x="8178800" y="9321800"/>
-            <a:ext cx="6096000" cy="508000"/>
+            <a:off x="8178800" y="9321799"/>
+            <a:ext cx="6096000" cy="508001"/>
           </a:xfrm>
           <a:prstGeom prst="rect">
             <a:avLst/>
@@ -21096,7 +21096,7 @@
         <p:spPr>
           <a:xfrm>
             <a:off x="14986000" y="9321800"/>
-            <a:ext cx="8128000" cy="495300"/>
+            <a:ext cx="8128000" cy="495301"/>
           </a:xfrm>
           <a:prstGeom prst="rect">
             <a:avLst/>
@@ -21143,8 +21143,8 @@
         </p:nvSpPr>
         <p:spPr>
           <a:xfrm>
-            <a:off x="1625600" y="10490200"/>
-            <a:ext cx="5080000" cy="508000"/>
+            <a:off x="1625600" y="10490199"/>
+            <a:ext cx="5080000" cy="508001"/>
           </a:xfrm>
           <a:prstGeom prst="rect">
             <a:avLst/>
@@ -21191,8 +21191,8 @@
         </p:nvSpPr>
         <p:spPr>
           <a:xfrm>
-            <a:off x="8178800" y="10490200"/>
-            <a:ext cx="6096000" cy="508000"/>
+            <a:off x="8178800" y="10490199"/>
+            <a:ext cx="6096000" cy="508001"/>
           </a:xfrm>
           <a:prstGeom prst="rect">
             <a:avLst/>
@@ -21240,7 +21240,7 @@
         <p:spPr>
           <a:xfrm>
             <a:off x="14986000" y="10490200"/>
-            <a:ext cx="8128000" cy="495300"/>
+            <a:ext cx="8128000" cy="495301"/>
           </a:xfrm>
           <a:prstGeom prst="rect">
             <a:avLst/>
@@ -21287,7 +21287,7 @@
         </p:nvSpPr>
         <p:spPr>
           <a:xfrm>
-            <a:off x="19650075" y="1016000"/>
+            <a:off x="19650075" y="1015999"/>
             <a:ext cx="3810000" cy="457201"/>
           </a:xfrm>
           <a:prstGeom prst="rect">
@@ -21335,7 +21335,7 @@
         </p:nvSpPr>
         <p:spPr>
           <a:xfrm>
-            <a:off x="19650075" y="1397000"/>
+            <a:off x="19650075" y="1396999"/>
             <a:ext cx="3810000" cy="457201"/>
           </a:xfrm>
           <a:prstGeom prst="rect">
@@ -21400,7 +21400,7 @@
         <p:spPr>
           <a:xfrm>
             <a:off x="18507075" y="990600"/>
-            <a:ext cx="914400" cy="914401"/>
+            <a:ext cx="914400" cy="914400"/>
           </a:xfrm>
           <a:prstGeom prst="rect">
             <a:avLst/>
@@ -21637,8 +21637,8 @@
         </p:nvSpPr>
         <p:spPr>
           <a:xfrm>
-            <a:off x="1320800" y="4724400"/>
-            <a:ext cx="10160000" cy="762000"/>
+            <a:off x="1320800" y="4724399"/>
+            <a:ext cx="10160000" cy="762001"/>
           </a:xfrm>
           <a:prstGeom prst="rect">
             <a:avLst/>
@@ -21686,7 +21686,7 @@
         <p:spPr>
           <a:xfrm>
             <a:off x="1320800" y="5486400"/>
-            <a:ext cx="10160000" cy="533400"/>
+            <a:ext cx="10160000" cy="533401"/>
           </a:xfrm>
           <a:prstGeom prst="rect">
             <a:avLst/>
@@ -21781,8 +21781,8 @@
         </p:nvSpPr>
         <p:spPr>
           <a:xfrm>
-            <a:off x="2133600" y="6604000"/>
-            <a:ext cx="7527561" cy="1042670"/>
+            <a:off x="2133600" y="6603999"/>
+            <a:ext cx="7527561" cy="1042671"/>
           </a:xfrm>
           <a:prstGeom prst="rect">
             <a:avLst/>
@@ -21877,8 +21877,8 @@
         </p:nvSpPr>
         <p:spPr>
           <a:xfrm>
-            <a:off x="2133600" y="8178800"/>
-            <a:ext cx="9652000" cy="1042670"/>
+            <a:off x="2133600" y="8178799"/>
+            <a:ext cx="9652000" cy="1042671"/>
           </a:xfrm>
           <a:prstGeom prst="rect">
             <a:avLst/>
@@ -21974,7 +21974,7 @@
         <p:spPr>
           <a:xfrm>
             <a:off x="2133600" y="9753600"/>
-            <a:ext cx="9652000" cy="596900"/>
+            <a:ext cx="9652000" cy="596901"/>
           </a:xfrm>
           <a:prstGeom prst="rect">
             <a:avLst/>
@@ -22021,8 +22021,8 @@
         </p:nvSpPr>
         <p:spPr>
           <a:xfrm>
-            <a:off x="12801600" y="4724400"/>
-            <a:ext cx="10160000" cy="762000"/>
+            <a:off x="12801600" y="4724399"/>
+            <a:ext cx="10160000" cy="762001"/>
           </a:xfrm>
           <a:prstGeom prst="rect">
             <a:avLst/>
@@ -22070,7 +22070,7 @@
         <p:spPr>
           <a:xfrm>
             <a:off x="12801600" y="5486400"/>
-            <a:ext cx="10160000" cy="533400"/>
+            <a:ext cx="10160000" cy="533401"/>
           </a:xfrm>
           <a:prstGeom prst="rect">
             <a:avLst/>
@@ -22165,8 +22165,8 @@
         </p:nvSpPr>
         <p:spPr>
           <a:xfrm>
-            <a:off x="13614400" y="6604000"/>
-            <a:ext cx="10160000" cy="1042670"/>
+            <a:off x="13614400" y="6603999"/>
+            <a:ext cx="9398000" cy="1042671"/>
           </a:xfrm>
           <a:prstGeom prst="rect">
             <a:avLst/>
@@ -22261,8 +22261,8 @@
         </p:nvSpPr>
         <p:spPr>
           <a:xfrm>
-            <a:off x="13614400" y="7955915"/>
-            <a:ext cx="9652000" cy="1042671"/>
+            <a:off x="13614400" y="7950200"/>
+            <a:ext cx="9398000" cy="1042670"/>
           </a:xfrm>
           <a:prstGeom prst="rect">
             <a:avLst/>
@@ -22357,8 +22357,8 @@
         </p:nvSpPr>
         <p:spPr>
           <a:xfrm>
-            <a:off x="13614400" y="9753600"/>
-            <a:ext cx="9652000" cy="1042670"/>
+            <a:off x="13614400" y="9753599"/>
+            <a:ext cx="9398000" cy="1042671"/>
           </a:xfrm>
           <a:prstGeom prst="rect">
             <a:avLst/>
@@ -23066,7 +23066,7 @@
         <p:spPr>
           <a:xfrm>
             <a:off x="1854200" y="9169400"/>
-            <a:ext cx="17780000" cy="558800"/>
+            <a:ext cx="17780000" cy="558801"/>
           </a:xfrm>
           <a:prstGeom prst="rect">
             <a:avLst/>
@@ -23120,7 +23120,7 @@
         <p:spPr>
           <a:xfrm>
             <a:off x="1854200" y="9652000"/>
-            <a:ext cx="17780000" cy="558800"/>
+            <a:ext cx="17780000" cy="558801"/>
           </a:xfrm>
           <a:prstGeom prst="rect">
             <a:avLst/>
@@ -25051,8 +25051,8 @@
         </p:blipFill>
         <p:spPr>
           <a:xfrm>
-            <a:off x="8737599" y="1371600"/>
-            <a:ext cx="1463041" cy="355600"/>
+            <a:off x="8737600" y="1371600"/>
+            <a:ext cx="1463040" cy="355600"/>
           </a:xfrm>
           <a:prstGeom prst="rect">
             <a:avLst/>
@@ -25138,8 +25138,8 @@
         </p:blipFill>
         <p:spPr>
           <a:xfrm>
-            <a:off x="17970499" y="1397000"/>
-            <a:ext cx="1891097" cy="292100"/>
+            <a:off x="17970500" y="1397000"/>
+            <a:ext cx="1891096" cy="292100"/>
           </a:xfrm>
           <a:prstGeom prst="rect">
             <a:avLst/>
@@ -25167,8 +25167,8 @@
         </p:blipFill>
         <p:spPr>
           <a:xfrm>
-            <a:off x="21272500" y="1371599"/>
-            <a:ext cx="1749425" cy="368301"/>
+            <a:off x="21272500" y="1371600"/>
+            <a:ext cx="1749425" cy="368300"/>
           </a:xfrm>
           <a:prstGeom prst="rect">
             <a:avLst/>
@@ -25196,8 +25196,8 @@
         </p:blipFill>
         <p:spPr>
           <a:xfrm>
-            <a:off x="1320799" y="2260599"/>
-            <a:ext cx="1747521" cy="330201"/>
+            <a:off x="1320800" y="2260600"/>
+            <a:ext cx="1747521" cy="330200"/>
           </a:xfrm>
           <a:prstGeom prst="rect">
             <a:avLst/>
@@ -25254,8 +25254,8 @@
         </p:blipFill>
         <p:spPr>
           <a:xfrm>
-            <a:off x="6667499" y="2222500"/>
-            <a:ext cx="1417808" cy="419100"/>
+            <a:off x="6667500" y="2222500"/>
+            <a:ext cx="1417807" cy="419100"/>
           </a:xfrm>
           <a:prstGeom prst="rect">
             <a:avLst/>
@@ -25312,8 +25312,8 @@
         </p:blipFill>
         <p:spPr>
           <a:xfrm>
-            <a:off x="11163299" y="2197100"/>
-            <a:ext cx="1238866" cy="457200"/>
+            <a:off x="11163300" y="2197100"/>
+            <a:ext cx="1238865" cy="457200"/>
           </a:xfrm>
           <a:prstGeom prst="rect">
             <a:avLst/>
@@ -25370,8 +25370,8 @@
         </p:blipFill>
         <p:spPr>
           <a:xfrm>
-            <a:off x="16598900" y="2197099"/>
-            <a:ext cx="1097281" cy="457201"/>
+            <a:off x="16598900" y="2197100"/>
+            <a:ext cx="1097281" cy="457200"/>
           </a:xfrm>
           <a:prstGeom prst="rect">
             <a:avLst/>
@@ -25400,7 +25400,7 @@
         <p:spPr>
           <a:xfrm>
             <a:off x="18745200" y="2247900"/>
-            <a:ext cx="1821039" cy="368301"/>
+            <a:ext cx="1821039" cy="368300"/>
           </a:xfrm>
           <a:prstGeom prst="rect">
             <a:avLst/>
@@ -25428,8 +25428,8 @@
         </p:blipFill>
         <p:spPr>
           <a:xfrm>
-            <a:off x="21590000" y="2222499"/>
-            <a:ext cx="1409430" cy="406401"/>
+            <a:off x="21590000" y="2222500"/>
+            <a:ext cx="1409430" cy="406400"/>
           </a:xfrm>
           <a:prstGeom prst="rect">
             <a:avLst/>
@@ -25486,7 +25486,7 @@
         </p:blipFill>
         <p:spPr>
           <a:xfrm>
-            <a:off x="4190999" y="3200400"/>
+            <a:off x="4191000" y="3200400"/>
             <a:ext cx="1432561" cy="215900"/>
           </a:xfrm>
           <a:prstGeom prst="rect">
@@ -25544,8 +25544,8 @@
         </p:blipFill>
         <p:spPr>
           <a:xfrm>
-            <a:off x="9766299" y="3149600"/>
-            <a:ext cx="1743558" cy="330201"/>
+            <a:off x="9766300" y="3149600"/>
+            <a:ext cx="1743556" cy="330200"/>
           </a:xfrm>
           <a:prstGeom prst="rect">
             <a:avLst/>
@@ -25603,7 +25603,7 @@
         <p:spPr>
           <a:xfrm>
             <a:off x="15748000" y="3124200"/>
-            <a:ext cx="1411817" cy="368301"/>
+            <a:ext cx="1411817" cy="368300"/>
           </a:xfrm>
           <a:prstGeom prst="rect">
             <a:avLst/>
@@ -25632,7 +25632,7 @@
         <p:spPr>
           <a:xfrm>
             <a:off x="18453100" y="3149600"/>
-            <a:ext cx="1733551" cy="330201"/>
+            <a:ext cx="1733550" cy="330200"/>
           </a:xfrm>
           <a:prstGeom prst="rect">
             <a:avLst/>
@@ -25690,7 +25690,7 @@
         <p:spPr>
           <a:xfrm>
             <a:off x="1320800" y="4013200"/>
-            <a:ext cx="2493698" cy="368301"/>
+            <a:ext cx="2493698" cy="368300"/>
           </a:xfrm>
           <a:prstGeom prst="rect">
             <a:avLst/>
@@ -25748,7 +25748,7 @@
         <p:spPr>
           <a:xfrm>
             <a:off x="7874000" y="3975100"/>
-            <a:ext cx="1301751" cy="444500"/>
+            <a:ext cx="1301750" cy="444500"/>
           </a:xfrm>
           <a:prstGeom prst="rect">
             <a:avLst/>
@@ -25777,7 +25777,7 @@
         <p:spPr>
           <a:xfrm>
             <a:off x="10426700" y="4013200"/>
-            <a:ext cx="1941248" cy="368301"/>
+            <a:ext cx="1941248" cy="368300"/>
           </a:xfrm>
           <a:prstGeom prst="rect">
             <a:avLst/>
@@ -25805,8 +25805,8 @@
         </p:blipFill>
         <p:spPr>
           <a:xfrm>
-            <a:off x="13601699" y="3962399"/>
-            <a:ext cx="853441" cy="457201"/>
+            <a:off x="13601700" y="3962400"/>
+            <a:ext cx="853440" cy="457200"/>
           </a:xfrm>
           <a:prstGeom prst="rect">
             <a:avLst/>
@@ -25834,8 +25834,8 @@
         </p:blipFill>
         <p:spPr>
           <a:xfrm>
-            <a:off x="15697199" y="4013200"/>
-            <a:ext cx="2084642" cy="355600"/>
+            <a:off x="15697200" y="4013200"/>
+            <a:ext cx="2084641" cy="355600"/>
           </a:xfrm>
           <a:prstGeom prst="rect">
             <a:avLst/>
@@ -25863,8 +25863,8 @@
         </p:blipFill>
         <p:spPr>
           <a:xfrm>
-            <a:off x="18986499" y="4013200"/>
-            <a:ext cx="1673413" cy="355600"/>
+            <a:off x="18986500" y="4013200"/>
+            <a:ext cx="1673412" cy="355600"/>
           </a:xfrm>
           <a:prstGeom prst="rect">
             <a:avLst/>
@@ -25893,7 +25893,7 @@
         <p:spPr>
           <a:xfrm>
             <a:off x="21882100" y="4013200"/>
-            <a:ext cx="1138150" cy="368301"/>
+            <a:ext cx="1138150" cy="368300"/>
           </a:xfrm>
           <a:prstGeom prst="rect">
             <a:avLst/>
@@ -25921,8 +25921,8 @@
         </p:blipFill>
         <p:spPr>
           <a:xfrm>
-            <a:off x="1320799" y="4914900"/>
-            <a:ext cx="1637898" cy="317500"/>
+            <a:off x="1320800" y="4914900"/>
+            <a:ext cx="1637897" cy="317500"/>
           </a:xfrm>
           <a:prstGeom prst="rect">
             <a:avLst/>
@@ -25950,8 +25950,8 @@
         </p:blipFill>
         <p:spPr>
           <a:xfrm>
-            <a:off x="4000500" y="4965699"/>
-            <a:ext cx="1498889" cy="228601"/>
+            <a:off x="4000500" y="4965700"/>
+            <a:ext cx="1498889" cy="228600"/>
           </a:xfrm>
           <a:prstGeom prst="rect">
             <a:avLst/>
@@ -25979,8 +25979,8 @@
         </p:blipFill>
         <p:spPr>
           <a:xfrm>
-            <a:off x="6502400" y="4902199"/>
-            <a:ext cx="2021840" cy="355601"/>
+            <a:off x="6502400" y="4902200"/>
+            <a:ext cx="2021840" cy="355600"/>
           </a:xfrm>
           <a:prstGeom prst="rect">
             <a:avLst/>
@@ -26037,8 +26037,8 @@
         </p:blipFill>
         <p:spPr>
           <a:xfrm>
-            <a:off x="11556999" y="4927600"/>
-            <a:ext cx="1828801" cy="304801"/>
+            <a:off x="11557000" y="4927600"/>
+            <a:ext cx="1828800" cy="304800"/>
           </a:xfrm>
           <a:prstGeom prst="rect">
             <a:avLst/>
@@ -26066,8 +26066,8 @@
         </p:blipFill>
         <p:spPr>
           <a:xfrm>
-            <a:off x="14452600" y="4889499"/>
-            <a:ext cx="971903" cy="368301"/>
+            <a:off x="14452600" y="4889500"/>
+            <a:ext cx="971903" cy="368300"/>
           </a:xfrm>
           <a:prstGeom prst="rect">
             <a:avLst/>
@@ -26095,8 +26095,8 @@
         </p:blipFill>
         <p:spPr>
           <a:xfrm>
-            <a:off x="16459200" y="4889499"/>
-            <a:ext cx="1401587" cy="368301"/>
+            <a:off x="16459200" y="4889500"/>
+            <a:ext cx="1401587" cy="368300"/>
           </a:xfrm>
           <a:prstGeom prst="rect">
             <a:avLst/>
@@ -26124,8 +26124,8 @@
         </p:blipFill>
         <p:spPr>
           <a:xfrm>
-            <a:off x="18884899" y="4965700"/>
-            <a:ext cx="1592581" cy="215901"/>
+            <a:off x="18884900" y="4965700"/>
+            <a:ext cx="1592581" cy="215900"/>
           </a:xfrm>
           <a:prstGeom prst="rect">
             <a:avLst/>
@@ -26153,8 +26153,8 @@
         </p:blipFill>
         <p:spPr>
           <a:xfrm>
-            <a:off x="21501099" y="4889500"/>
-            <a:ext cx="1516681" cy="368300"/>
+            <a:off x="21501100" y="4889500"/>
+            <a:ext cx="1516680" cy="368300"/>
           </a:xfrm>
           <a:prstGeom prst="rect">
             <a:avLst/>
@@ -26183,7 +26183,7 @@
         <p:spPr>
           <a:xfrm>
             <a:off x="1320800" y="5778500"/>
-            <a:ext cx="2519275" cy="368301"/>
+            <a:ext cx="2519275" cy="368300"/>
           </a:xfrm>
           <a:prstGeom prst="rect">
             <a:avLst/>
@@ -26270,7 +26270,7 @@
         <p:spPr>
           <a:xfrm>
             <a:off x="11607800" y="5854700"/>
-            <a:ext cx="1802514" cy="215900"/>
+            <a:ext cx="1802515" cy="215900"/>
           </a:xfrm>
           <a:prstGeom prst="rect">
             <a:avLst/>
@@ -26328,7 +26328,7 @@
         <p:spPr>
           <a:xfrm>
             <a:off x="17983200" y="5803900"/>
-            <a:ext cx="2243528" cy="304801"/>
+            <a:ext cx="2243528" cy="304800"/>
           </a:xfrm>
           <a:prstGeom prst="rect">
             <a:avLst/>
@@ -26357,7 +26357,7 @@
         <p:spPr>
           <a:xfrm>
             <a:off x="21793200" y="5778500"/>
-            <a:ext cx="1225110" cy="368301"/>
+            <a:ext cx="1225110" cy="368300"/>
           </a:xfrm>
           <a:prstGeom prst="rect">
             <a:avLst/>
@@ -26385,8 +26385,8 @@
         </p:blipFill>
         <p:spPr>
           <a:xfrm>
-            <a:off x="1320800" y="6654799"/>
-            <a:ext cx="1127919" cy="368301"/>
+            <a:off x="1320800" y="6654800"/>
+            <a:ext cx="1127919" cy="368300"/>
           </a:xfrm>
           <a:prstGeom prst="rect">
             <a:avLst/>
@@ -26414,8 +26414,8 @@
         </p:blipFill>
         <p:spPr>
           <a:xfrm>
-            <a:off x="3492499" y="6654800"/>
-            <a:ext cx="1808252" cy="368301"/>
+            <a:off x="3492500" y="6654800"/>
+            <a:ext cx="1808251" cy="368300"/>
           </a:xfrm>
           <a:prstGeom prst="rect">
             <a:avLst/>
@@ -26444,7 +26444,7 @@
         <p:spPr>
           <a:xfrm>
             <a:off x="6337300" y="6616700"/>
-            <a:ext cx="1200150" cy="457201"/>
+            <a:ext cx="1200150" cy="457200"/>
           </a:xfrm>
           <a:prstGeom prst="rect">
             <a:avLst/>
@@ -26472,8 +26472,8 @@
         </p:blipFill>
         <p:spPr>
           <a:xfrm>
-            <a:off x="8585200" y="6654799"/>
-            <a:ext cx="1557603" cy="368301"/>
+            <a:off x="8585200" y="6654800"/>
+            <a:ext cx="1557603" cy="368300"/>
           </a:xfrm>
           <a:prstGeom prst="rect">
             <a:avLst/>
@@ -26530,8 +26530,8 @@
         </p:blipFill>
         <p:spPr>
           <a:xfrm>
-            <a:off x="13881099" y="6629400"/>
-            <a:ext cx="1345225" cy="431800"/>
+            <a:off x="13881100" y="6629400"/>
+            <a:ext cx="1345224" cy="431800"/>
           </a:xfrm>
           <a:prstGeom prst="rect">
             <a:avLst/>
@@ -26559,8 +26559,8 @@
         </p:blipFill>
         <p:spPr>
           <a:xfrm>
-            <a:off x="16281400" y="6667499"/>
-            <a:ext cx="1397190" cy="342901"/>
+            <a:off x="16281400" y="6667500"/>
+            <a:ext cx="1397190" cy="342900"/>
           </a:xfrm>
           <a:prstGeom prst="rect">
             <a:avLst/>
@@ -26647,7 +26647,7 @@
         <p:spPr>
           <a:xfrm>
             <a:off x="1320800" y="7518400"/>
-            <a:ext cx="1408177" cy="419100"/>
+            <a:ext cx="1408176" cy="419100"/>
           </a:xfrm>
           <a:prstGeom prst="rect">
             <a:avLst/>
@@ -26676,7 +26676,7 @@
         <p:spPr>
           <a:xfrm>
             <a:off x="3695700" y="7543800"/>
-            <a:ext cx="1750060" cy="355601"/>
+            <a:ext cx="1750061" cy="355600"/>
           </a:xfrm>
           <a:prstGeom prst="rect">
             <a:avLst/>
@@ -26704,8 +26704,8 @@
         </p:blipFill>
         <p:spPr>
           <a:xfrm>
-            <a:off x="6438899" y="7543799"/>
-            <a:ext cx="1790349" cy="368301"/>
+            <a:off x="6438900" y="7543800"/>
+            <a:ext cx="1790348" cy="368300"/>
           </a:xfrm>
           <a:prstGeom prst="rect">
             <a:avLst/>
@@ -26791,8 +26791,8 @@
         </p:blipFill>
         <p:spPr>
           <a:xfrm>
-            <a:off x="14744699" y="7556500"/>
-            <a:ext cx="1153200" cy="330201"/>
+            <a:off x="14744700" y="7556500"/>
+            <a:ext cx="1153199" cy="330200"/>
           </a:xfrm>
           <a:prstGeom prst="rect">
             <a:avLst/>
@@ -26820,8 +26820,8 @@
         </p:blipFill>
         <p:spPr>
           <a:xfrm>
-            <a:off x="16891000" y="7543799"/>
-            <a:ext cx="1676400" cy="355601"/>
+            <a:off x="16891000" y="7543800"/>
+            <a:ext cx="1676400" cy="355600"/>
           </a:xfrm>
           <a:prstGeom prst="rect">
             <a:avLst/>
@@ -26849,8 +26849,8 @@
         </p:blipFill>
         <p:spPr>
           <a:xfrm>
-            <a:off x="19532600" y="7581899"/>
-            <a:ext cx="1335481" cy="279401"/>
+            <a:off x="19532600" y="7581900"/>
+            <a:ext cx="1335481" cy="279400"/>
           </a:xfrm>
           <a:prstGeom prst="rect">
             <a:avLst/>
@@ -26907,8 +26907,8 @@
         </p:blipFill>
         <p:spPr>
           <a:xfrm>
-            <a:off x="1320799" y="8420100"/>
-            <a:ext cx="2125399" cy="368300"/>
+            <a:off x="1320800" y="8420100"/>
+            <a:ext cx="2125398" cy="368300"/>
           </a:xfrm>
           <a:prstGeom prst="rect">
             <a:avLst/>
@@ -26937,7 +26937,7 @@
         <p:spPr>
           <a:xfrm>
             <a:off x="4622800" y="8432800"/>
-            <a:ext cx="1212945" cy="342901"/>
+            <a:ext cx="1212945" cy="342900"/>
           </a:xfrm>
           <a:prstGeom prst="rect">
             <a:avLst/>
@@ -26965,8 +26965,8 @@
         </p:blipFill>
         <p:spPr>
           <a:xfrm>
-            <a:off x="7035799" y="8381999"/>
-            <a:ext cx="763525" cy="457201"/>
+            <a:off x="7035800" y="8382000"/>
+            <a:ext cx="763524" cy="457200"/>
           </a:xfrm>
           <a:prstGeom prst="rect">
             <a:avLst/>
@@ -26994,8 +26994,8 @@
         </p:blipFill>
         <p:spPr>
           <a:xfrm>
-            <a:off x="8991599" y="8420099"/>
-            <a:ext cx="2557640" cy="368301"/>
+            <a:off x="8991600" y="8420100"/>
+            <a:ext cx="2557639" cy="368300"/>
           </a:xfrm>
           <a:prstGeom prst="rect">
             <a:avLst/>
@@ -27053,7 +27053,7 @@
         <p:spPr>
           <a:xfrm>
             <a:off x="16052800" y="8420100"/>
-            <a:ext cx="1539699" cy="368301"/>
+            <a:ext cx="1539699" cy="368300"/>
           </a:xfrm>
           <a:prstGeom prst="rect">
             <a:avLst/>
@@ -27082,7 +27082,7 @@
         <p:spPr>
           <a:xfrm>
             <a:off x="18783300" y="8432800"/>
-            <a:ext cx="1572127" cy="355601"/>
+            <a:ext cx="1572127" cy="355600"/>
           </a:xfrm>
           <a:prstGeom prst="rect">
             <a:avLst/>
@@ -27110,8 +27110,8 @@
         </p:blipFill>
         <p:spPr>
           <a:xfrm>
-            <a:off x="21577300" y="8420099"/>
-            <a:ext cx="1445066" cy="368301"/>
+            <a:off x="21577300" y="8420100"/>
+            <a:ext cx="1445066" cy="368300"/>
           </a:xfrm>
           <a:prstGeom prst="rect">
             <a:avLst/>
@@ -27139,8 +27139,8 @@
         </p:blipFill>
         <p:spPr>
           <a:xfrm>
-            <a:off x="1320799" y="9309100"/>
-            <a:ext cx="1351281" cy="355601"/>
+            <a:off x="1320800" y="9309100"/>
+            <a:ext cx="1351281" cy="355600"/>
           </a:xfrm>
           <a:prstGeom prst="rect">
             <a:avLst/>
@@ -27168,8 +27168,8 @@
         </p:blipFill>
         <p:spPr>
           <a:xfrm>
-            <a:off x="3924300" y="9309099"/>
-            <a:ext cx="1424905" cy="355601"/>
+            <a:off x="3924300" y="9309100"/>
+            <a:ext cx="1424905" cy="355600"/>
           </a:xfrm>
           <a:prstGeom prst="rect">
             <a:avLst/>
@@ -27197,8 +27197,8 @@
         </p:blipFill>
         <p:spPr>
           <a:xfrm>
-            <a:off x="6642099" y="9309100"/>
-            <a:ext cx="2204686" cy="368300"/>
+            <a:off x="6642100" y="9309100"/>
+            <a:ext cx="2204685" cy="368300"/>
           </a:xfrm>
           <a:prstGeom prst="rect">
             <a:avLst/>
@@ -27255,8 +27255,8 @@
         </p:blipFill>
         <p:spPr>
           <a:xfrm>
-            <a:off x="12738099" y="9309099"/>
-            <a:ext cx="1718735" cy="355601"/>
+            <a:off x="12738100" y="9309100"/>
+            <a:ext cx="1718734" cy="355600"/>
           </a:xfrm>
           <a:prstGeom prst="rect">
             <a:avLst/>
@@ -27284,8 +27284,8 @@
         </p:blipFill>
         <p:spPr>
           <a:xfrm>
-            <a:off x="15684500" y="9321799"/>
-            <a:ext cx="1694330" cy="342901"/>
+            <a:off x="15684500" y="9321800"/>
+            <a:ext cx="1694330" cy="342900"/>
           </a:xfrm>
           <a:prstGeom prst="rect">
             <a:avLst/>
@@ -27314,7 +27314,7 @@
         <p:spPr>
           <a:xfrm>
             <a:off x="18643600" y="9283700"/>
-            <a:ext cx="1466574" cy="406401"/>
+            <a:ext cx="1466574" cy="406400"/>
           </a:xfrm>
           <a:prstGeom prst="rect">
             <a:avLst/>
@@ -27342,8 +27342,8 @@
         </p:blipFill>
         <p:spPr>
           <a:xfrm>
-            <a:off x="21348699" y="9321800"/>
-            <a:ext cx="1645105" cy="342900"/>
+            <a:off x="21348700" y="9321800"/>
+            <a:ext cx="1645104" cy="342900"/>
           </a:xfrm>
           <a:prstGeom prst="rect">
             <a:avLst/>
@@ -27372,7 +27372,7 @@
         <p:spPr>
           <a:xfrm>
             <a:off x="1320800" y="10185400"/>
-            <a:ext cx="2268626" cy="368301"/>
+            <a:ext cx="2268626" cy="368300"/>
           </a:xfrm>
           <a:prstGeom prst="rect">
             <a:avLst/>
@@ -27429,8 +27429,8 @@
         </p:blipFill>
         <p:spPr>
           <a:xfrm>
-            <a:off x="7137399" y="10172699"/>
-            <a:ext cx="1440874" cy="406401"/>
+            <a:off x="7137400" y="10172700"/>
+            <a:ext cx="1440873" cy="406400"/>
           </a:xfrm>
           <a:prstGeom prst="rect">
             <a:avLst/>
@@ -27458,8 +27458,8 @@
         </p:blipFill>
         <p:spPr>
           <a:xfrm>
-            <a:off x="9575800" y="10147299"/>
-            <a:ext cx="1097280" cy="457201"/>
+            <a:off x="9575800" y="10147300"/>
+            <a:ext cx="1097281" cy="457200"/>
           </a:xfrm>
           <a:prstGeom prst="rect">
             <a:avLst/>
@@ -27516,8 +27516,8 @@
         </p:blipFill>
         <p:spPr>
           <a:xfrm>
-            <a:off x="14058900" y="10185399"/>
-            <a:ext cx="989807" cy="368301"/>
+            <a:off x="14058900" y="10185400"/>
+            <a:ext cx="989807" cy="368300"/>
           </a:xfrm>
           <a:prstGeom prst="rect">
             <a:avLst/>
@@ -27604,7 +27604,7 @@
         <p:spPr>
           <a:xfrm>
             <a:off x="21539200" y="10185400"/>
-            <a:ext cx="1485989" cy="368301"/>
+            <a:ext cx="1485989" cy="368300"/>
           </a:xfrm>
           <a:prstGeom prst="rect">
             <a:avLst/>
@@ -27632,8 +27632,8 @@
         </p:blipFill>
         <p:spPr>
           <a:xfrm>
-            <a:off x="1320800" y="11087099"/>
-            <a:ext cx="1796446" cy="330201"/>
+            <a:off x="1320800" y="11087100"/>
+            <a:ext cx="1796446" cy="330200"/>
           </a:xfrm>
           <a:prstGeom prst="rect">
             <a:avLst/>
@@ -27662,7 +27662,7 @@
         <p:spPr>
           <a:xfrm>
             <a:off x="4508500" y="11074400"/>
-            <a:ext cx="1171399" cy="368301"/>
+            <a:ext cx="1171399" cy="368300"/>
           </a:xfrm>
           <a:prstGeom prst="rect">
             <a:avLst/>
@@ -27690,8 +27690,8 @@
         </p:blipFill>
         <p:spPr>
           <a:xfrm>
-            <a:off x="7086600" y="11074399"/>
-            <a:ext cx="1397000" cy="355601"/>
+            <a:off x="7086600" y="11074400"/>
+            <a:ext cx="1397000" cy="355600"/>
           </a:xfrm>
           <a:prstGeom prst="rect">
             <a:avLst/>
@@ -27719,8 +27719,8 @@
         </p:blipFill>
         <p:spPr>
           <a:xfrm>
-            <a:off x="9893300" y="11074399"/>
-            <a:ext cx="1397000" cy="355601"/>
+            <a:off x="9893300" y="11074400"/>
+            <a:ext cx="1397000" cy="355600"/>
           </a:xfrm>
           <a:prstGeom prst="rect">
             <a:avLst/>
@@ -27778,7 +27778,7 @@
         <p:spPr>
           <a:xfrm>
             <a:off x="15697200" y="11074400"/>
-            <a:ext cx="1829653" cy="342900"/>
+            <a:ext cx="1829654" cy="342900"/>
           </a:xfrm>
           <a:prstGeom prst="rect">
             <a:avLst/>
@@ -27806,8 +27806,8 @@
         </p:blipFill>
         <p:spPr>
           <a:xfrm>
-            <a:off x="18923000" y="11074399"/>
-            <a:ext cx="1537141" cy="368301"/>
+            <a:off x="18923000" y="11074400"/>
+            <a:ext cx="1537141" cy="368300"/>
           </a:xfrm>
           <a:prstGeom prst="rect">
             <a:avLst/>
@@ -27836,7 +27836,7 @@
         <p:spPr>
           <a:xfrm>
             <a:off x="21856700" y="11074400"/>
-            <a:ext cx="1163726" cy="368301"/>
+            <a:ext cx="1163726" cy="368300"/>
           </a:xfrm>
           <a:prstGeom prst="rect">
             <a:avLst/>
@@ -28054,8 +28054,8 @@
         </p:blipFill>
         <p:spPr>
           <a:xfrm>
-            <a:off x="8737599" y="1371600"/>
-            <a:ext cx="1463041" cy="355600"/>
+            <a:off x="8737600" y="1371600"/>
+            <a:ext cx="1463040" cy="355600"/>
           </a:xfrm>
           <a:prstGeom prst="rect">
             <a:avLst/>
@@ -28141,8 +28141,8 @@
         </p:blipFill>
         <p:spPr>
           <a:xfrm>
-            <a:off x="17970499" y="1397000"/>
-            <a:ext cx="1891097" cy="292100"/>
+            <a:off x="17970500" y="1397000"/>
+            <a:ext cx="1891096" cy="292100"/>
           </a:xfrm>
           <a:prstGeom prst="rect">
             <a:avLst/>
@@ -28170,8 +28170,8 @@
         </p:blipFill>
         <p:spPr>
           <a:xfrm>
-            <a:off x="21272500" y="1371599"/>
-            <a:ext cx="1749425" cy="368301"/>
+            <a:off x="21272500" y="1371600"/>
+            <a:ext cx="1749425" cy="368300"/>
           </a:xfrm>
           <a:prstGeom prst="rect">
             <a:avLst/>
@@ -28199,8 +28199,8 @@
         </p:blipFill>
         <p:spPr>
           <a:xfrm>
-            <a:off x="1320799" y="2260599"/>
-            <a:ext cx="1747521" cy="330201"/>
+            <a:off x="1320800" y="2260600"/>
+            <a:ext cx="1747521" cy="330200"/>
           </a:xfrm>
           <a:prstGeom prst="rect">
             <a:avLst/>
@@ -28257,8 +28257,8 @@
         </p:blipFill>
         <p:spPr>
           <a:xfrm>
-            <a:off x="6667499" y="2222500"/>
-            <a:ext cx="1417808" cy="419100"/>
+            <a:off x="6667500" y="2222500"/>
+            <a:ext cx="1417807" cy="419100"/>
           </a:xfrm>
           <a:prstGeom prst="rect">
             <a:avLst/>
@@ -28315,8 +28315,8 @@
         </p:blipFill>
         <p:spPr>
           <a:xfrm>
-            <a:off x="11163299" y="2197100"/>
-            <a:ext cx="1238866" cy="457200"/>
+            <a:off x="11163300" y="2197100"/>
+            <a:ext cx="1238865" cy="457200"/>
           </a:xfrm>
           <a:prstGeom prst="rect">
             <a:avLst/>
@@ -28373,8 +28373,8 @@
         </p:blipFill>
         <p:spPr>
           <a:xfrm>
-            <a:off x="16598900" y="2197099"/>
-            <a:ext cx="1097281" cy="457201"/>
+            <a:off x="16598900" y="2197100"/>
+            <a:ext cx="1097281" cy="457200"/>
           </a:xfrm>
           <a:prstGeom prst="rect">
             <a:avLst/>
@@ -28403,7 +28403,7 @@
         <p:spPr>
           <a:xfrm>
             <a:off x="18745200" y="2247900"/>
-            <a:ext cx="1821039" cy="368301"/>
+            <a:ext cx="1821039" cy="368300"/>
           </a:xfrm>
           <a:prstGeom prst="rect">
             <a:avLst/>
@@ -28431,8 +28431,8 @@
         </p:blipFill>
         <p:spPr>
           <a:xfrm>
-            <a:off x="21590000" y="2222499"/>
-            <a:ext cx="1409430" cy="406401"/>
+            <a:off x="21590000" y="2222500"/>
+            <a:ext cx="1409430" cy="406400"/>
           </a:xfrm>
           <a:prstGeom prst="rect">
             <a:avLst/>
@@ -28489,7 +28489,7 @@
         </p:blipFill>
         <p:spPr>
           <a:xfrm>
-            <a:off x="4190999" y="3200400"/>
+            <a:off x="4191000" y="3200400"/>
             <a:ext cx="1432561" cy="215900"/>
           </a:xfrm>
           <a:prstGeom prst="rect">
@@ -28547,8 +28547,8 @@
         </p:blipFill>
         <p:spPr>
           <a:xfrm>
-            <a:off x="9766299" y="3149600"/>
-            <a:ext cx="1743558" cy="330201"/>
+            <a:off x="9766300" y="3149600"/>
+            <a:ext cx="1743556" cy="330200"/>
           </a:xfrm>
           <a:prstGeom prst="rect">
             <a:avLst/>
@@ -28606,7 +28606,7 @@
         <p:spPr>
           <a:xfrm>
             <a:off x="15748000" y="3124200"/>
-            <a:ext cx="1411817" cy="368301"/>
+            <a:ext cx="1411817" cy="368300"/>
           </a:xfrm>
           <a:prstGeom prst="rect">
             <a:avLst/>
@@ -28635,7 +28635,7 @@
         <p:spPr>
           <a:xfrm>
             <a:off x="18453100" y="3149600"/>
-            <a:ext cx="1733551" cy="330201"/>
+            <a:ext cx="1733550" cy="330200"/>
           </a:xfrm>
           <a:prstGeom prst="rect">
             <a:avLst/>
@@ -28693,7 +28693,7 @@
         <p:spPr>
           <a:xfrm>
             <a:off x="1320800" y="4013200"/>
-            <a:ext cx="2493698" cy="368301"/>
+            <a:ext cx="2493698" cy="368300"/>
           </a:xfrm>
           <a:prstGeom prst="rect">
             <a:avLst/>
@@ -28751,7 +28751,7 @@
         <p:spPr>
           <a:xfrm>
             <a:off x="7874000" y="3975100"/>
-            <a:ext cx="1301751" cy="444500"/>
+            <a:ext cx="1301750" cy="444500"/>
           </a:xfrm>
           <a:prstGeom prst="rect">
             <a:avLst/>
@@ -28780,7 +28780,7 @@
         <p:spPr>
           <a:xfrm>
             <a:off x="10426700" y="4013200"/>
-            <a:ext cx="1941248" cy="368301"/>
+            <a:ext cx="1941248" cy="368300"/>
           </a:xfrm>
           <a:prstGeom prst="rect">
             <a:avLst/>
@@ -28808,8 +28808,8 @@
         </p:blipFill>
         <p:spPr>
           <a:xfrm>
-            <a:off x="13601699" y="3962399"/>
-            <a:ext cx="853441" cy="457201"/>
+            <a:off x="13601700" y="3962400"/>
+            <a:ext cx="853440" cy="457200"/>
           </a:xfrm>
           <a:prstGeom prst="rect">
             <a:avLst/>
@@ -28837,8 +28837,8 @@
         </p:blipFill>
         <p:spPr>
           <a:xfrm>
-            <a:off x="15697199" y="4013200"/>
-            <a:ext cx="2084642" cy="355600"/>
+            <a:off x="15697200" y="4013200"/>
+            <a:ext cx="2084641" cy="355600"/>
           </a:xfrm>
           <a:prstGeom prst="rect">
             <a:avLst/>
@@ -28866,8 +28866,8 @@
         </p:blipFill>
         <p:spPr>
           <a:xfrm>
-            <a:off x="18986499" y="4013200"/>
-            <a:ext cx="1673413" cy="355600"/>
+            <a:off x="18986500" y="4013200"/>
+            <a:ext cx="1673412" cy="355600"/>
           </a:xfrm>
           <a:prstGeom prst="rect">
             <a:avLst/>
@@ -28896,7 +28896,7 @@
         <p:spPr>
           <a:xfrm>
             <a:off x="21882100" y="4013200"/>
-            <a:ext cx="1138150" cy="368301"/>
+            <a:ext cx="1138150" cy="368300"/>
           </a:xfrm>
           <a:prstGeom prst="rect">
             <a:avLst/>
@@ -28924,8 +28924,8 @@
         </p:blipFill>
         <p:spPr>
           <a:xfrm>
-            <a:off x="1320799" y="4914900"/>
-            <a:ext cx="1637898" cy="317500"/>
+            <a:off x="1320800" y="4914900"/>
+            <a:ext cx="1637897" cy="317500"/>
           </a:xfrm>
           <a:prstGeom prst="rect">
             <a:avLst/>
@@ -28953,8 +28953,8 @@
         </p:blipFill>
         <p:spPr>
           <a:xfrm>
-            <a:off x="4000500" y="4965699"/>
-            <a:ext cx="1498889" cy="228601"/>
+            <a:off x="4000500" y="4965700"/>
+            <a:ext cx="1498889" cy="228600"/>
           </a:xfrm>
           <a:prstGeom prst="rect">
             <a:avLst/>
@@ -28982,8 +28982,8 @@
         </p:blipFill>
         <p:spPr>
           <a:xfrm>
-            <a:off x="6502400" y="4902199"/>
-            <a:ext cx="2021840" cy="355601"/>
+            <a:off x="6502400" y="4902200"/>
+            <a:ext cx="2021840" cy="355600"/>
           </a:xfrm>
           <a:prstGeom prst="rect">
             <a:avLst/>
@@ -29040,8 +29040,8 @@
         </p:blipFill>
         <p:spPr>
           <a:xfrm>
-            <a:off x="11556999" y="4927600"/>
-            <a:ext cx="1828801" cy="304801"/>
+            <a:off x="11557000" y="4927600"/>
+            <a:ext cx="1828800" cy="304800"/>
           </a:xfrm>
           <a:prstGeom prst="rect">
             <a:avLst/>
@@ -29069,8 +29069,8 @@
         </p:blipFill>
         <p:spPr>
           <a:xfrm>
-            <a:off x="14452600" y="4889499"/>
-            <a:ext cx="971903" cy="368301"/>
+            <a:off x="14452600" y="4889500"/>
+            <a:ext cx="971903" cy="368300"/>
           </a:xfrm>
           <a:prstGeom prst="rect">
             <a:avLst/>
@@ -29098,8 +29098,8 @@
         </p:blipFill>
         <p:spPr>
           <a:xfrm>
-            <a:off x="16459200" y="4889499"/>
-            <a:ext cx="1401587" cy="368301"/>
+            <a:off x="16459200" y="4889500"/>
+            <a:ext cx="1401587" cy="368300"/>
           </a:xfrm>
           <a:prstGeom prst="rect">
             <a:avLst/>
@@ -29127,8 +29127,8 @@
         </p:blipFill>
         <p:spPr>
           <a:xfrm>
-            <a:off x="18884899" y="4965700"/>
-            <a:ext cx="1592581" cy="215901"/>
+            <a:off x="18884900" y="4965700"/>
+            <a:ext cx="1592581" cy="215900"/>
           </a:xfrm>
           <a:prstGeom prst="rect">
             <a:avLst/>
@@ -29156,8 +29156,8 @@
         </p:blipFill>
         <p:spPr>
           <a:xfrm>
-            <a:off x="21501099" y="4889500"/>
-            <a:ext cx="1516681" cy="368300"/>
+            <a:off x="21501100" y="4889500"/>
+            <a:ext cx="1516680" cy="368300"/>
           </a:xfrm>
           <a:prstGeom prst="rect">
             <a:avLst/>
@@ -29186,7 +29186,7 @@
         <p:spPr>
           <a:xfrm>
             <a:off x="1320800" y="5778500"/>
-            <a:ext cx="2519275" cy="368301"/>
+            <a:ext cx="2519275" cy="368300"/>
           </a:xfrm>
           <a:prstGeom prst="rect">
             <a:avLst/>
@@ -29273,7 +29273,7 @@
         <p:spPr>
           <a:xfrm>
             <a:off x="11607800" y="5854700"/>
-            <a:ext cx="1802514" cy="215900"/>
+            <a:ext cx="1802515" cy="215900"/>
           </a:xfrm>
           <a:prstGeom prst="rect">
             <a:avLst/>
@@ -29331,7 +29331,7 @@
         <p:spPr>
           <a:xfrm>
             <a:off x="17983200" y="5803900"/>
-            <a:ext cx="2243528" cy="304801"/>
+            <a:ext cx="2243528" cy="304800"/>
           </a:xfrm>
           <a:prstGeom prst="rect">
             <a:avLst/>
@@ -29360,7 +29360,7 @@
         <p:spPr>
           <a:xfrm>
             <a:off x="21793200" y="5778500"/>
-            <a:ext cx="1225110" cy="368301"/>
+            <a:ext cx="1225110" cy="368300"/>
           </a:xfrm>
           <a:prstGeom prst="rect">
             <a:avLst/>
@@ -29388,8 +29388,8 @@
         </p:blipFill>
         <p:spPr>
           <a:xfrm>
-            <a:off x="1320800" y="6654799"/>
-            <a:ext cx="1127919" cy="368301"/>
+            <a:off x="1320800" y="6654800"/>
+            <a:ext cx="1127919" cy="368300"/>
           </a:xfrm>
           <a:prstGeom prst="rect">
             <a:avLst/>
@@ -29417,8 +29417,8 @@
         </p:blipFill>
         <p:spPr>
           <a:xfrm>
-            <a:off x="3492499" y="6654800"/>
-            <a:ext cx="1808252" cy="368301"/>
+            <a:off x="3492500" y="6654800"/>
+            <a:ext cx="1808251" cy="368300"/>
           </a:xfrm>
           <a:prstGeom prst="rect">
             <a:avLst/>
@@ -29447,7 +29447,7 @@
         <p:spPr>
           <a:xfrm>
             <a:off x="6337300" y="6616700"/>
-            <a:ext cx="1200150" cy="457201"/>
+            <a:ext cx="1200150" cy="457200"/>
           </a:xfrm>
           <a:prstGeom prst="rect">
             <a:avLst/>
@@ -29475,8 +29475,8 @@
         </p:blipFill>
         <p:spPr>
           <a:xfrm>
-            <a:off x="8585200" y="6654799"/>
-            <a:ext cx="1557603" cy="368301"/>
+            <a:off x="8585200" y="6654800"/>
+            <a:ext cx="1557603" cy="368300"/>
           </a:xfrm>
           <a:prstGeom prst="rect">
             <a:avLst/>
@@ -29533,8 +29533,8 @@
         </p:blipFill>
         <p:spPr>
           <a:xfrm>
-            <a:off x="13881099" y="6629400"/>
-            <a:ext cx="1345225" cy="431800"/>
+            <a:off x="13881100" y="6629400"/>
+            <a:ext cx="1345224" cy="431800"/>
           </a:xfrm>
           <a:prstGeom prst="rect">
             <a:avLst/>
@@ -29562,8 +29562,8 @@
         </p:blipFill>
         <p:spPr>
           <a:xfrm>
-            <a:off x="16281400" y="6667499"/>
-            <a:ext cx="1397190" cy="342901"/>
+            <a:off x="16281400" y="6667500"/>
+            <a:ext cx="1397190" cy="342900"/>
           </a:xfrm>
           <a:prstGeom prst="rect">
             <a:avLst/>
@@ -29650,7 +29650,7 @@
         <p:spPr>
           <a:xfrm>
             <a:off x="1320800" y="7518400"/>
-            <a:ext cx="1408177" cy="419100"/>
+            <a:ext cx="1408176" cy="419100"/>
           </a:xfrm>
           <a:prstGeom prst="rect">
             <a:avLst/>
@@ -29679,7 +29679,7 @@
         <p:spPr>
           <a:xfrm>
             <a:off x="3695700" y="7543800"/>
-            <a:ext cx="1750060" cy="355601"/>
+            <a:ext cx="1750061" cy="355600"/>
           </a:xfrm>
           <a:prstGeom prst="rect">
             <a:avLst/>
@@ -29707,8 +29707,8 @@
         </p:blipFill>
         <p:spPr>
           <a:xfrm>
-            <a:off x="6438899" y="7543799"/>
-            <a:ext cx="1790349" cy="368301"/>
+            <a:off x="6438900" y="7543800"/>
+            <a:ext cx="1790348" cy="368300"/>
           </a:xfrm>
           <a:prstGeom prst="rect">
             <a:avLst/>
@@ -29794,8 +29794,8 @@
         </p:blipFill>
         <p:spPr>
           <a:xfrm>
-            <a:off x="14744699" y="7556500"/>
-            <a:ext cx="1153200" cy="330201"/>
+            <a:off x="14744700" y="7556500"/>
+            <a:ext cx="1153199" cy="330200"/>
           </a:xfrm>
           <a:prstGeom prst="rect">
             <a:avLst/>
@@ -29823,8 +29823,8 @@
         </p:blipFill>
         <p:spPr>
           <a:xfrm>
-            <a:off x="16891000" y="7543799"/>
-            <a:ext cx="1676400" cy="355601"/>
+            <a:off x="16891000" y="7543800"/>
+            <a:ext cx="1676400" cy="355600"/>
           </a:xfrm>
           <a:prstGeom prst="rect">
             <a:avLst/>
@@ -29852,8 +29852,8 @@
         </p:blipFill>
         <p:spPr>
           <a:xfrm>
-            <a:off x="19532600" y="7581899"/>
-            <a:ext cx="1335481" cy="279401"/>
+            <a:off x="19532600" y="7581900"/>
+            <a:ext cx="1335481" cy="279400"/>
           </a:xfrm>
           <a:prstGeom prst="rect">
             <a:avLst/>
@@ -29910,8 +29910,8 @@
         </p:blipFill>
         <p:spPr>
           <a:xfrm>
-            <a:off x="1320799" y="8420100"/>
-            <a:ext cx="2125399" cy="368300"/>
+            <a:off x="1320800" y="8420100"/>
+            <a:ext cx="2125398" cy="368300"/>
           </a:xfrm>
           <a:prstGeom prst="rect">
             <a:avLst/>
@@ -29940,7 +29940,7 @@
         <p:spPr>
           <a:xfrm>
             <a:off x="4622800" y="8432800"/>
-            <a:ext cx="1212945" cy="342901"/>
+            <a:ext cx="1212945" cy="342900"/>
           </a:xfrm>
           <a:prstGeom prst="rect">
             <a:avLst/>
@@ -29968,8 +29968,8 @@
         </p:blipFill>
         <p:spPr>
           <a:xfrm>
-            <a:off x="7035799" y="8381999"/>
-            <a:ext cx="763525" cy="457201"/>
+            <a:off x="7035800" y="8382000"/>
+            <a:ext cx="763524" cy="457200"/>
           </a:xfrm>
           <a:prstGeom prst="rect">
             <a:avLst/>
@@ -29997,8 +29997,8 @@
         </p:blipFill>
         <p:spPr>
           <a:xfrm>
-            <a:off x="8991599" y="8420099"/>
-            <a:ext cx="2557640" cy="368301"/>
+            <a:off x="8991600" y="8420100"/>
+            <a:ext cx="2557639" cy="368300"/>
           </a:xfrm>
           <a:prstGeom prst="rect">
             <a:avLst/>
@@ -30056,7 +30056,7 @@
         <p:spPr>
           <a:xfrm>
             <a:off x="16052800" y="8420100"/>
-            <a:ext cx="1539699" cy="368301"/>
+            <a:ext cx="1539699" cy="368300"/>
           </a:xfrm>
           <a:prstGeom prst="rect">
             <a:avLst/>
@@ -30085,7 +30085,7 @@
         <p:spPr>
           <a:xfrm>
             <a:off x="18783300" y="8432800"/>
-            <a:ext cx="1572127" cy="355601"/>
+            <a:ext cx="1572127" cy="355600"/>
           </a:xfrm>
           <a:prstGeom prst="rect">
             <a:avLst/>
@@ -30113,8 +30113,8 @@
         </p:blipFill>
         <p:spPr>
           <a:xfrm>
-            <a:off x="21577300" y="8420099"/>
-            <a:ext cx="1445066" cy="368301"/>
+            <a:off x="21577300" y="8420100"/>
+            <a:ext cx="1445066" cy="368300"/>
           </a:xfrm>
           <a:prstGeom prst="rect">
             <a:avLst/>
@@ -30142,8 +30142,8 @@
         </p:blipFill>
         <p:spPr>
           <a:xfrm>
-            <a:off x="1320799" y="9309100"/>
-            <a:ext cx="1351281" cy="355601"/>
+            <a:off x="1320800" y="9309100"/>
+            <a:ext cx="1351281" cy="355600"/>
           </a:xfrm>
           <a:prstGeom prst="rect">
             <a:avLst/>
@@ -30171,8 +30171,8 @@
         </p:blipFill>
         <p:spPr>
           <a:xfrm>
-            <a:off x="3924300" y="9309099"/>
-            <a:ext cx="1424905" cy="355601"/>
+            <a:off x="3924300" y="9309100"/>
+            <a:ext cx="1424905" cy="355600"/>
           </a:xfrm>
           <a:prstGeom prst="rect">
             <a:avLst/>
@@ -30200,8 +30200,8 @@
         </p:blipFill>
         <p:spPr>
           <a:xfrm>
-            <a:off x="6642099" y="9309100"/>
-            <a:ext cx="2204686" cy="368300"/>
+            <a:off x="6642100" y="9309100"/>
+            <a:ext cx="2204685" cy="368300"/>
           </a:xfrm>
           <a:prstGeom prst="rect">
             <a:avLst/>
@@ -30258,8 +30258,8 @@
         </p:blipFill>
         <p:spPr>
           <a:xfrm>
-            <a:off x="12738099" y="9309099"/>
-            <a:ext cx="1718735" cy="355601"/>
+            <a:off x="12738100" y="9309100"/>
+            <a:ext cx="1718734" cy="355600"/>
           </a:xfrm>
           <a:prstGeom prst="rect">
             <a:avLst/>
@@ -30287,8 +30287,8 @@
         </p:blipFill>
         <p:spPr>
           <a:xfrm>
-            <a:off x="15684500" y="9321799"/>
-            <a:ext cx="1694330" cy="342901"/>
+            <a:off x="15684500" y="9321800"/>
+            <a:ext cx="1694330" cy="342900"/>
           </a:xfrm>
           <a:prstGeom prst="rect">
             <a:avLst/>
@@ -30317,7 +30317,7 @@
         <p:spPr>
           <a:xfrm>
             <a:off x="18643600" y="9283700"/>
-            <a:ext cx="1466574" cy="406401"/>
+            <a:ext cx="1466574" cy="406400"/>
           </a:xfrm>
           <a:prstGeom prst="rect">
             <a:avLst/>
@@ -30345,8 +30345,8 @@
         </p:blipFill>
         <p:spPr>
           <a:xfrm>
-            <a:off x="21348699" y="9321800"/>
-            <a:ext cx="1645105" cy="342900"/>
+            <a:off x="21348700" y="9321800"/>
+            <a:ext cx="1645104" cy="342900"/>
           </a:xfrm>
           <a:prstGeom prst="rect">
             <a:avLst/>
@@ -30375,7 +30375,7 @@
         <p:spPr>
           <a:xfrm>
             <a:off x="1320800" y="10185400"/>
-            <a:ext cx="2268626" cy="368301"/>
+            <a:ext cx="2268626" cy="368300"/>
           </a:xfrm>
           <a:prstGeom prst="rect">
             <a:avLst/>
@@ -30432,8 +30432,8 @@
         </p:blipFill>
         <p:spPr>
           <a:xfrm>
-            <a:off x="7137399" y="10172699"/>
-            <a:ext cx="1440874" cy="406401"/>
+            <a:off x="7137400" y="10172700"/>
+            <a:ext cx="1440873" cy="406400"/>
           </a:xfrm>
           <a:prstGeom prst="rect">
             <a:avLst/>
@@ -30461,8 +30461,8 @@
         </p:blipFill>
         <p:spPr>
           <a:xfrm>
-            <a:off x="9575800" y="10147299"/>
-            <a:ext cx="1097280" cy="457201"/>
+            <a:off x="9575800" y="10147300"/>
+            <a:ext cx="1097281" cy="457200"/>
           </a:xfrm>
           <a:prstGeom prst="rect">
             <a:avLst/>
@@ -30519,8 +30519,8 @@
         </p:blipFill>
         <p:spPr>
           <a:xfrm>
-            <a:off x="14058900" y="10185399"/>
-            <a:ext cx="989807" cy="368301"/>
+            <a:off x="14058900" y="10185400"/>
+            <a:ext cx="989807" cy="368300"/>
           </a:xfrm>
           <a:prstGeom prst="rect">
             <a:avLst/>
@@ -30607,7 +30607,7 @@
         <p:spPr>
           <a:xfrm>
             <a:off x="21539200" y="10185400"/>
-            <a:ext cx="1485989" cy="368301"/>
+            <a:ext cx="1485989" cy="368300"/>
           </a:xfrm>
           <a:prstGeom prst="rect">
             <a:avLst/>
@@ -30635,8 +30635,8 @@
         </p:blipFill>
         <p:spPr>
           <a:xfrm>
-            <a:off x="1320800" y="11087099"/>
-            <a:ext cx="1796446" cy="330201"/>
+            <a:off x="1320800" y="11087100"/>
+            <a:ext cx="1796446" cy="330200"/>
           </a:xfrm>
           <a:prstGeom prst="rect">
             <a:avLst/>
@@ -30665,7 +30665,7 @@
         <p:spPr>
           <a:xfrm>
             <a:off x="4508500" y="11074400"/>
-            <a:ext cx="1171399" cy="368301"/>
+            <a:ext cx="1171399" cy="368300"/>
           </a:xfrm>
           <a:prstGeom prst="rect">
             <a:avLst/>
@@ -30693,8 +30693,8 @@
         </p:blipFill>
         <p:spPr>
           <a:xfrm>
-            <a:off x="7086600" y="11074399"/>
-            <a:ext cx="1397000" cy="355601"/>
+            <a:off x="7086600" y="11074400"/>
+            <a:ext cx="1397000" cy="355600"/>
           </a:xfrm>
           <a:prstGeom prst="rect">
             <a:avLst/>
@@ -30722,8 +30722,8 @@
         </p:blipFill>
         <p:spPr>
           <a:xfrm>
-            <a:off x="9893300" y="11074399"/>
-            <a:ext cx="1397000" cy="355601"/>
+            <a:off x="9893300" y="11074400"/>
+            <a:ext cx="1397000" cy="355600"/>
           </a:xfrm>
           <a:prstGeom prst="rect">
             <a:avLst/>
@@ -30781,7 +30781,7 @@
         <p:spPr>
           <a:xfrm>
             <a:off x="15697200" y="11074400"/>
-            <a:ext cx="1829653" cy="342900"/>
+            <a:ext cx="1829654" cy="342900"/>
           </a:xfrm>
           <a:prstGeom prst="rect">
             <a:avLst/>
@@ -30809,8 +30809,8 @@
         </p:blipFill>
         <p:spPr>
           <a:xfrm>
-            <a:off x="18923000" y="11074399"/>
-            <a:ext cx="1537141" cy="368301"/>
+            <a:off x="18923000" y="11074400"/>
+            <a:ext cx="1537141" cy="368300"/>
           </a:xfrm>
           <a:prstGeom prst="rect">
             <a:avLst/>
@@ -30839,7 +30839,7 @@
         <p:spPr>
           <a:xfrm>
             <a:off x="21856700" y="11074400"/>
-            <a:ext cx="1163726" cy="368301"/>
+            <a:ext cx="1163726" cy="368300"/>
           </a:xfrm>
           <a:prstGeom prst="rect">
             <a:avLst/>

</xml_diff>